<commit_message>
Teachers' Day: cover line from Linnea, Ib third in row three, logo bottom right on mentor slides
Co-Authored-By: Claude Opus 5.5 <noreply@anthropic.com>
Claude-Session: https://claude.ai/code/session_014HGzAbxBh54nuyJHG7tse8
</commit_message>
<xml_diff>
--- a/templates/posts/october/05-10-2026-mon-ig-teachers-day-grid-tests.pptx
+++ b/templates/posts/october/05-10-2026-mon-ig-teachers-day-grid-tests.pptx
@@ -8045,7 +8045,7 @@
       </p:pic>
       <p:pic>
         <p:nvPicPr>
-          <p:cNvPr id="71" name="Picture 70" descr="3139326610849488932.jpg"/>
+          <p:cNvPr id="71" name="Picture 70" descr="5210732961209071061.jpg"/>
           <p:cNvPicPr>
             <a:picLocks noChangeAspect="1"/>
           </p:cNvPicPr>
@@ -8076,6 +8076,510 @@
         <p:spPr>
           <a:xfrm>
             <a:off x="5200650" y="3962400"/>
+            <a:ext cx="2143125" cy="285750"/>
+          </a:xfrm>
+          <a:prstGeom prst="rect">
+            <a:avLst/>
+          </a:prstGeom>
+          <a:noFill/>
+        </p:spPr>
+        <p:txBody>
+          <a:bodyPr wrap="square" lIns="0" rIns="0" tIns="0" bIns="0" anchor="t">
+            <a:spAutoFit/>
+          </a:bodyPr>
+          <a:lstStyle/>
+          <a:p>
+            <a:pPr algn="l">
+              <a:lnSpc>
+                <a:spcPct val="120000"/>
+              </a:lnSpc>
+            </a:pPr>
+            <a:r>
+              <a:rPr sz="1800" b="0" i="0">
+                <a:solidFill>
+                  <a:srgbClr val="333130"/>
+                </a:solidFill>
+                <a:latin typeface="Source Sans 3"/>
+              </a:rPr>
+              <a:t>Delvin Solkinson</a:t>
+            </a:r>
+          </a:p>
+        </p:txBody>
+      </p:sp>
+      <p:pic>
+        <p:nvPicPr>
+          <p:cNvPr id="73" name="Picture 72" descr="2809537841490521723.jpg"/>
+          <p:cNvPicPr>
+            <a:picLocks noChangeAspect="1"/>
+          </p:cNvPicPr>
+          <p:nvPr/>
+        </p:nvPicPr>
+        <p:blipFill>
+          <a:blip r:embed="rId5"/>
+          <a:stretch>
+            <a:fillRect/>
+          </a:stretch>
+        </p:blipFill>
+        <p:spPr>
+          <a:xfrm>
+            <a:off x="7458075" y="1762125"/>
+            <a:ext cx="2143125" cy="2143125"/>
+          </a:xfrm>
+          <a:prstGeom prst="rect">
+            <a:avLst/>
+          </a:prstGeom>
+        </p:spPr>
+      </p:pic>
+      <p:sp>
+        <p:nvSpPr>
+          <p:cNvPr id="74" name="TextBox 73"/>
+          <p:cNvSpPr txBox="1"/>
+          <p:nvPr/>
+        </p:nvSpPr>
+        <p:spPr>
+          <a:xfrm>
+            <a:off x="7458075" y="3962400"/>
+            <a:ext cx="2143125" cy="285750"/>
+          </a:xfrm>
+          <a:prstGeom prst="rect">
+            <a:avLst/>
+          </a:prstGeom>
+          <a:noFill/>
+        </p:spPr>
+        <p:txBody>
+          <a:bodyPr wrap="square" lIns="0" rIns="0" tIns="0" bIns="0" anchor="t">
+            <a:spAutoFit/>
+          </a:bodyPr>
+          <a:lstStyle/>
+          <a:p>
+            <a:pPr algn="l">
+              <a:lnSpc>
+                <a:spcPct val="120000"/>
+              </a:lnSpc>
+            </a:pPr>
+            <a:r>
+              <a:rPr sz="1800" b="0" i="0">
+                <a:solidFill>
+                  <a:srgbClr val="333130"/>
+                </a:solidFill>
+                <a:latin typeface="Source Sans 3"/>
+              </a:rPr>
+              <a:t>Brian Daubenspeck</a:t>
+            </a:r>
+          </a:p>
+        </p:txBody>
+      </p:sp>
+      <p:pic>
+        <p:nvPicPr>
+          <p:cNvPr id="75" name="Picture 74" descr="8537488814558054651.jpg"/>
+          <p:cNvPicPr>
+            <a:picLocks noChangeAspect="1"/>
+          </p:cNvPicPr>
+          <p:nvPr/>
+        </p:nvPicPr>
+        <p:blipFill>
+          <a:blip r:embed="rId6"/>
+          <a:stretch>
+            <a:fillRect/>
+          </a:stretch>
+        </p:blipFill>
+        <p:spPr>
+          <a:xfrm>
+            <a:off x="685800" y="4381500"/>
+            <a:ext cx="2143125" cy="2143125"/>
+          </a:xfrm>
+          <a:prstGeom prst="rect">
+            <a:avLst/>
+          </a:prstGeom>
+        </p:spPr>
+      </p:pic>
+      <p:sp>
+        <p:nvSpPr>
+          <p:cNvPr id="76" name="TextBox 75"/>
+          <p:cNvSpPr txBox="1"/>
+          <p:nvPr/>
+        </p:nvSpPr>
+        <p:spPr>
+          <a:xfrm>
+            <a:off x="685800" y="6581775"/>
+            <a:ext cx="2143125" cy="285750"/>
+          </a:xfrm>
+          <a:prstGeom prst="rect">
+            <a:avLst/>
+          </a:prstGeom>
+          <a:noFill/>
+        </p:spPr>
+        <p:txBody>
+          <a:bodyPr wrap="square" lIns="0" rIns="0" tIns="0" bIns="0" anchor="t">
+            <a:spAutoFit/>
+          </a:bodyPr>
+          <a:lstStyle/>
+          <a:p>
+            <a:pPr algn="l">
+              <a:lnSpc>
+                <a:spcPct val="120000"/>
+              </a:lnSpc>
+            </a:pPr>
+            <a:r>
+              <a:rPr sz="1800" b="0" i="0">
+                <a:solidFill>
+                  <a:srgbClr val="333130"/>
+                </a:solidFill>
+                <a:latin typeface="Source Sans 3"/>
+              </a:rPr>
+              <a:t>Elena Kalli</a:t>
+            </a:r>
+          </a:p>
+        </p:txBody>
+      </p:sp>
+      <p:pic>
+        <p:nvPicPr>
+          <p:cNvPr id="77" name="Picture 76" descr="1871177202792540355.jpg"/>
+          <p:cNvPicPr>
+            <a:picLocks noChangeAspect="1"/>
+          </p:cNvPicPr>
+          <p:nvPr/>
+        </p:nvPicPr>
+        <p:blipFill>
+          <a:blip r:embed="rId7"/>
+          <a:stretch>
+            <a:fillRect/>
+          </a:stretch>
+        </p:blipFill>
+        <p:spPr>
+          <a:xfrm>
+            <a:off x="2943225" y="4381500"/>
+            <a:ext cx="2143125" cy="2143125"/>
+          </a:xfrm>
+          <a:prstGeom prst="rect">
+            <a:avLst/>
+          </a:prstGeom>
+        </p:spPr>
+      </p:pic>
+      <p:sp>
+        <p:nvSpPr>
+          <p:cNvPr id="78" name="TextBox 77"/>
+          <p:cNvSpPr txBox="1"/>
+          <p:nvPr/>
+        </p:nvSpPr>
+        <p:spPr>
+          <a:xfrm>
+            <a:off x="2943225" y="6581775"/>
+            <a:ext cx="2143125" cy="285750"/>
+          </a:xfrm>
+          <a:prstGeom prst="rect">
+            <a:avLst/>
+          </a:prstGeom>
+          <a:noFill/>
+        </p:spPr>
+        <p:txBody>
+          <a:bodyPr wrap="square" lIns="0" rIns="0" tIns="0" bIns="0" anchor="t">
+            <a:spAutoFit/>
+          </a:bodyPr>
+          <a:lstStyle/>
+          <a:p>
+            <a:pPr algn="l">
+              <a:lnSpc>
+                <a:spcPct val="120000"/>
+              </a:lnSpc>
+            </a:pPr>
+            <a:r>
+              <a:rPr sz="1800" b="0" i="0">
+                <a:solidFill>
+                  <a:srgbClr val="333130"/>
+                </a:solidFill>
+                <a:latin typeface="Source Sans 3"/>
+              </a:rPr>
+              <a:t>Nick Padwick</a:t>
+            </a:r>
+          </a:p>
+        </p:txBody>
+      </p:sp>
+      <p:pic>
+        <p:nvPicPr>
+          <p:cNvPr id="79" name="Picture 78" descr="3121827617327194404.jpg"/>
+          <p:cNvPicPr>
+            <a:picLocks noChangeAspect="1"/>
+          </p:cNvPicPr>
+          <p:nvPr/>
+        </p:nvPicPr>
+        <p:blipFill>
+          <a:blip r:embed="rId8"/>
+          <a:stretch>
+            <a:fillRect/>
+          </a:stretch>
+        </p:blipFill>
+        <p:spPr>
+          <a:xfrm>
+            <a:off x="5200650" y="4381500"/>
+            <a:ext cx="2143125" cy="2143125"/>
+          </a:xfrm>
+          <a:prstGeom prst="rect">
+            <a:avLst/>
+          </a:prstGeom>
+        </p:spPr>
+      </p:pic>
+      <p:sp>
+        <p:nvSpPr>
+          <p:cNvPr id="80" name="TextBox 79"/>
+          <p:cNvSpPr txBox="1"/>
+          <p:nvPr/>
+        </p:nvSpPr>
+        <p:spPr>
+          <a:xfrm>
+            <a:off x="5200650" y="6581775"/>
+            <a:ext cx="2143125" cy="285750"/>
+          </a:xfrm>
+          <a:prstGeom prst="rect">
+            <a:avLst/>
+          </a:prstGeom>
+          <a:noFill/>
+        </p:spPr>
+        <p:txBody>
+          <a:bodyPr wrap="square" lIns="0" rIns="0" tIns="0" bIns="0" anchor="t">
+            <a:spAutoFit/>
+          </a:bodyPr>
+          <a:lstStyle/>
+          <a:p>
+            <a:pPr algn="l">
+              <a:lnSpc>
+                <a:spcPct val="120000"/>
+              </a:lnSpc>
+            </a:pPr>
+            <a:r>
+              <a:rPr sz="1800" b="0" i="0">
+                <a:solidFill>
+                  <a:srgbClr val="333130"/>
+                </a:solidFill>
+                <a:latin typeface="Source Sans 3"/>
+              </a:rPr>
+              <a:t>Carla Portugal</a:t>
+            </a:r>
+          </a:p>
+        </p:txBody>
+      </p:sp>
+      <p:pic>
+        <p:nvPicPr>
+          <p:cNvPr id="81" name="Picture 80" descr="2935389191544078019.jpg"/>
+          <p:cNvPicPr>
+            <a:picLocks noChangeAspect="1"/>
+          </p:cNvPicPr>
+          <p:nvPr/>
+        </p:nvPicPr>
+        <p:blipFill>
+          <a:blip r:embed="rId9"/>
+          <a:stretch>
+            <a:fillRect/>
+          </a:stretch>
+        </p:blipFill>
+        <p:spPr>
+          <a:xfrm>
+            <a:off x="7458075" y="4381500"/>
+            <a:ext cx="2143125" cy="2143125"/>
+          </a:xfrm>
+          <a:prstGeom prst="rect">
+            <a:avLst/>
+          </a:prstGeom>
+        </p:spPr>
+      </p:pic>
+      <p:sp>
+        <p:nvSpPr>
+          <p:cNvPr id="82" name="TextBox 81"/>
+          <p:cNvSpPr txBox="1"/>
+          <p:nvPr/>
+        </p:nvSpPr>
+        <p:spPr>
+          <a:xfrm>
+            <a:off x="7458075" y="6581775"/>
+            <a:ext cx="2143125" cy="285750"/>
+          </a:xfrm>
+          <a:prstGeom prst="rect">
+            <a:avLst/>
+          </a:prstGeom>
+          <a:noFill/>
+        </p:spPr>
+        <p:txBody>
+          <a:bodyPr wrap="square" lIns="0" rIns="0" tIns="0" bIns="0" anchor="t">
+            <a:spAutoFit/>
+          </a:bodyPr>
+          <a:lstStyle/>
+          <a:p>
+            <a:pPr algn="l">
+              <a:lnSpc>
+                <a:spcPct val="120000"/>
+              </a:lnSpc>
+            </a:pPr>
+            <a:r>
+              <a:rPr sz="1800" b="0" i="0">
+                <a:solidFill>
+                  <a:srgbClr val="333130"/>
+                </a:solidFill>
+                <a:latin typeface="Source Sans 3"/>
+              </a:rPr>
+              <a:t>Gerald Ramírez</a:t>
+            </a:r>
+          </a:p>
+        </p:txBody>
+      </p:sp>
+      <p:pic>
+        <p:nvPicPr>
+          <p:cNvPr id="83" name="Picture 82" descr="2459370116124079744.jpg"/>
+          <p:cNvPicPr>
+            <a:picLocks noChangeAspect="1"/>
+          </p:cNvPicPr>
+          <p:nvPr/>
+        </p:nvPicPr>
+        <p:blipFill>
+          <a:blip r:embed="rId10"/>
+          <a:stretch>
+            <a:fillRect/>
+          </a:stretch>
+        </p:blipFill>
+        <p:spPr>
+          <a:xfrm>
+            <a:off x="685800" y="7000875"/>
+            <a:ext cx="2143125" cy="2143125"/>
+          </a:xfrm>
+          <a:prstGeom prst="rect">
+            <a:avLst/>
+          </a:prstGeom>
+        </p:spPr>
+      </p:pic>
+      <p:sp>
+        <p:nvSpPr>
+          <p:cNvPr id="84" name="TextBox 83"/>
+          <p:cNvSpPr txBox="1"/>
+          <p:nvPr/>
+        </p:nvSpPr>
+        <p:spPr>
+          <a:xfrm>
+            <a:off x="685800" y="9201150"/>
+            <a:ext cx="2143125" cy="285750"/>
+          </a:xfrm>
+          <a:prstGeom prst="rect">
+            <a:avLst/>
+          </a:prstGeom>
+          <a:noFill/>
+        </p:spPr>
+        <p:txBody>
+          <a:bodyPr wrap="square" lIns="0" rIns="0" tIns="0" bIns="0" anchor="t">
+            <a:spAutoFit/>
+          </a:bodyPr>
+          <a:lstStyle/>
+          <a:p>
+            <a:pPr algn="l">
+              <a:lnSpc>
+                <a:spcPct val="120000"/>
+              </a:lnSpc>
+            </a:pPr>
+            <a:r>
+              <a:rPr sz="1800" b="0" i="0">
+                <a:solidFill>
+                  <a:srgbClr val="333130"/>
+                </a:solidFill>
+                <a:latin typeface="Source Sans 3"/>
+              </a:rPr>
+              <a:t>Wesley Sander</a:t>
+            </a:r>
+          </a:p>
+        </p:txBody>
+      </p:sp>
+      <p:pic>
+        <p:nvPicPr>
+          <p:cNvPr id="85" name="Picture 84" descr="5232482427252906244.jpg"/>
+          <p:cNvPicPr>
+            <a:picLocks noChangeAspect="1"/>
+          </p:cNvPicPr>
+          <p:nvPr/>
+        </p:nvPicPr>
+        <p:blipFill>
+          <a:blip r:embed="rId11"/>
+          <a:stretch>
+            <a:fillRect/>
+          </a:stretch>
+        </p:blipFill>
+        <p:spPr>
+          <a:xfrm>
+            <a:off x="2943225" y="7000875"/>
+            <a:ext cx="2143125" cy="2143125"/>
+          </a:xfrm>
+          <a:prstGeom prst="rect">
+            <a:avLst/>
+          </a:prstGeom>
+        </p:spPr>
+      </p:pic>
+      <p:sp>
+        <p:nvSpPr>
+          <p:cNvPr id="86" name="TextBox 85"/>
+          <p:cNvSpPr txBox="1"/>
+          <p:nvPr/>
+        </p:nvSpPr>
+        <p:spPr>
+          <a:xfrm>
+            <a:off x="2943225" y="9201150"/>
+            <a:ext cx="2143125" cy="285750"/>
+          </a:xfrm>
+          <a:prstGeom prst="rect">
+            <a:avLst/>
+          </a:prstGeom>
+          <a:noFill/>
+        </p:spPr>
+        <p:txBody>
+          <a:bodyPr wrap="square" lIns="0" rIns="0" tIns="0" bIns="0" anchor="t">
+            <a:spAutoFit/>
+          </a:bodyPr>
+          <a:lstStyle/>
+          <a:p>
+            <a:pPr algn="l">
+              <a:lnSpc>
+                <a:spcPct val="120000"/>
+              </a:lnSpc>
+            </a:pPr>
+            <a:r>
+              <a:rPr sz="1800" b="0" i="0">
+                <a:solidFill>
+                  <a:srgbClr val="333130"/>
+                </a:solidFill>
+                <a:latin typeface="Source Sans 3"/>
+              </a:rPr>
+              <a:t>Isadora Shmidt</a:t>
+            </a:r>
+          </a:p>
+        </p:txBody>
+      </p:sp>
+      <p:pic>
+        <p:nvPicPr>
+          <p:cNvPr id="87" name="Picture 86" descr="6273480043131842505.jpg"/>
+          <p:cNvPicPr>
+            <a:picLocks noChangeAspect="1"/>
+          </p:cNvPicPr>
+          <p:nvPr/>
+        </p:nvPicPr>
+        <p:blipFill>
+          <a:blip r:embed="rId12"/>
+          <a:stretch>
+            <a:fillRect/>
+          </a:stretch>
+        </p:blipFill>
+        <p:spPr>
+          <a:xfrm>
+            <a:off x="5200650" y="7000875"/>
+            <a:ext cx="2143125" cy="2143125"/>
+          </a:xfrm>
+          <a:prstGeom prst="rect">
+            <a:avLst/>
+          </a:prstGeom>
+        </p:spPr>
+      </p:pic>
+      <p:sp>
+        <p:nvSpPr>
+          <p:cNvPr id="88" name="TextBox 87"/>
+          <p:cNvSpPr txBox="1"/>
+          <p:nvPr/>
+        </p:nvSpPr>
+        <p:spPr>
+          <a:xfrm>
+            <a:off x="5200650" y="9201150"/>
             <a:ext cx="2143125" cy="285750"/>
           </a:xfrm>
           <a:prstGeom prst="rect">
@@ -8108,511 +8612,7 @@
       </p:sp>
       <p:pic>
         <p:nvPicPr>
-          <p:cNvPr id="73" name="Picture 72" descr="5798608773535107475.jpg"/>
-          <p:cNvPicPr>
-            <a:picLocks noChangeAspect="1"/>
-          </p:cNvPicPr>
-          <p:nvPr/>
-        </p:nvPicPr>
-        <p:blipFill>
-          <a:blip r:embed="rId5"/>
-          <a:stretch>
-            <a:fillRect/>
-          </a:stretch>
-        </p:blipFill>
-        <p:spPr>
-          <a:xfrm>
-            <a:off x="7458075" y="1762125"/>
-            <a:ext cx="2143125" cy="2143125"/>
-          </a:xfrm>
-          <a:prstGeom prst="rect">
-            <a:avLst/>
-          </a:prstGeom>
-        </p:spPr>
-      </p:pic>
-      <p:sp>
-        <p:nvSpPr>
-          <p:cNvPr id="74" name="TextBox 73"/>
-          <p:cNvSpPr txBox="1"/>
-          <p:nvPr/>
-        </p:nvSpPr>
-        <p:spPr>
-          <a:xfrm>
-            <a:off x="7458075" y="3962400"/>
-            <a:ext cx="2143125" cy="285750"/>
-          </a:xfrm>
-          <a:prstGeom prst="rect">
-            <a:avLst/>
-          </a:prstGeom>
-          <a:noFill/>
-        </p:spPr>
-        <p:txBody>
-          <a:bodyPr wrap="square" lIns="0" rIns="0" tIns="0" bIns="0" anchor="t">
-            <a:spAutoFit/>
-          </a:bodyPr>
-          <a:lstStyle/>
-          <a:p>
-            <a:pPr algn="l">
-              <a:lnSpc>
-                <a:spcPct val="120000"/>
-              </a:lnSpc>
-            </a:pPr>
-            <a:r>
-              <a:rPr sz="1800" b="0" i="0">
-                <a:solidFill>
-                  <a:srgbClr val="333130"/>
-                </a:solidFill>
-                <a:latin typeface="Source Sans 3"/>
-              </a:rPr>
-              <a:t>Brian Daubenspeck</a:t>
-            </a:r>
-          </a:p>
-        </p:txBody>
-      </p:sp>
-      <p:pic>
-        <p:nvPicPr>
-          <p:cNvPr id="75" name="Picture 74" descr="2750903348445113879.jpg"/>
-          <p:cNvPicPr>
-            <a:picLocks noChangeAspect="1"/>
-          </p:cNvPicPr>
-          <p:nvPr/>
-        </p:nvPicPr>
-        <p:blipFill>
-          <a:blip r:embed="rId6"/>
-          <a:stretch>
-            <a:fillRect/>
-          </a:stretch>
-        </p:blipFill>
-        <p:spPr>
-          <a:xfrm>
-            <a:off x="685800" y="4381500"/>
-            <a:ext cx="2143125" cy="2143125"/>
-          </a:xfrm>
-          <a:prstGeom prst="rect">
-            <a:avLst/>
-          </a:prstGeom>
-        </p:spPr>
-      </p:pic>
-      <p:sp>
-        <p:nvSpPr>
-          <p:cNvPr id="76" name="TextBox 75"/>
-          <p:cNvSpPr txBox="1"/>
-          <p:nvPr/>
-        </p:nvSpPr>
-        <p:spPr>
-          <a:xfrm>
-            <a:off x="685800" y="6581775"/>
-            <a:ext cx="2143125" cy="285750"/>
-          </a:xfrm>
-          <a:prstGeom prst="rect">
-            <a:avLst/>
-          </a:prstGeom>
-          <a:noFill/>
-        </p:spPr>
-        <p:txBody>
-          <a:bodyPr wrap="square" lIns="0" rIns="0" tIns="0" bIns="0" anchor="t">
-            <a:spAutoFit/>
-          </a:bodyPr>
-          <a:lstStyle/>
-          <a:p>
-            <a:pPr algn="l">
-              <a:lnSpc>
-                <a:spcPct val="120000"/>
-              </a:lnSpc>
-            </a:pPr>
-            <a:r>
-              <a:rPr sz="1800" b="0" i="0">
-                <a:solidFill>
-                  <a:srgbClr val="333130"/>
-                </a:solidFill>
-                <a:latin typeface="Source Sans 3"/>
-              </a:rPr>
-              <a:t>Elena Kalli</a:t>
-            </a:r>
-          </a:p>
-        </p:txBody>
-      </p:sp>
-      <p:pic>
-        <p:nvPicPr>
-          <p:cNvPr id="77" name="Picture 76" descr="7250826599254344975.jpg"/>
-          <p:cNvPicPr>
-            <a:picLocks noChangeAspect="1"/>
-          </p:cNvPicPr>
-          <p:nvPr/>
-        </p:nvPicPr>
-        <p:blipFill>
-          <a:blip r:embed="rId7"/>
-          <a:stretch>
-            <a:fillRect/>
-          </a:stretch>
-        </p:blipFill>
-        <p:spPr>
-          <a:xfrm>
-            <a:off x="2943225" y="4381500"/>
-            <a:ext cx="2143125" cy="2143125"/>
-          </a:xfrm>
-          <a:prstGeom prst="rect">
-            <a:avLst/>
-          </a:prstGeom>
-        </p:spPr>
-      </p:pic>
-      <p:sp>
-        <p:nvSpPr>
-          <p:cNvPr id="78" name="TextBox 77"/>
-          <p:cNvSpPr txBox="1"/>
-          <p:nvPr/>
-        </p:nvSpPr>
-        <p:spPr>
-          <a:xfrm>
-            <a:off x="2943225" y="6581775"/>
-            <a:ext cx="2143125" cy="285750"/>
-          </a:xfrm>
-          <a:prstGeom prst="rect">
-            <a:avLst/>
-          </a:prstGeom>
-          <a:noFill/>
-        </p:spPr>
-        <p:txBody>
-          <a:bodyPr wrap="square" lIns="0" rIns="0" tIns="0" bIns="0" anchor="t">
-            <a:spAutoFit/>
-          </a:bodyPr>
-          <a:lstStyle/>
-          <a:p>
-            <a:pPr algn="l">
-              <a:lnSpc>
-                <a:spcPct val="120000"/>
-              </a:lnSpc>
-            </a:pPr>
-            <a:r>
-              <a:rPr sz="1800" b="0" i="0">
-                <a:solidFill>
-                  <a:srgbClr val="333130"/>
-                </a:solidFill>
-                <a:latin typeface="Source Sans 3"/>
-              </a:rPr>
-              <a:t>Nick Padwick</a:t>
-            </a:r>
-          </a:p>
-        </p:txBody>
-      </p:sp>
-      <p:pic>
-        <p:nvPicPr>
-          <p:cNvPr id="79" name="Picture 78" descr="8694088384298960110.jpg"/>
-          <p:cNvPicPr>
-            <a:picLocks noChangeAspect="1"/>
-          </p:cNvPicPr>
-          <p:nvPr/>
-        </p:nvPicPr>
-        <p:blipFill>
-          <a:blip r:embed="rId8"/>
-          <a:stretch>
-            <a:fillRect/>
-          </a:stretch>
-        </p:blipFill>
-        <p:spPr>
-          <a:xfrm>
-            <a:off x="5200650" y="4381500"/>
-            <a:ext cx="2143125" cy="2143125"/>
-          </a:xfrm>
-          <a:prstGeom prst="rect">
-            <a:avLst/>
-          </a:prstGeom>
-        </p:spPr>
-      </p:pic>
-      <p:sp>
-        <p:nvSpPr>
-          <p:cNvPr id="80" name="TextBox 79"/>
-          <p:cNvSpPr txBox="1"/>
-          <p:nvPr/>
-        </p:nvSpPr>
-        <p:spPr>
-          <a:xfrm>
-            <a:off x="5200650" y="6581775"/>
-            <a:ext cx="2143125" cy="285750"/>
-          </a:xfrm>
-          <a:prstGeom prst="rect">
-            <a:avLst/>
-          </a:prstGeom>
-          <a:noFill/>
-        </p:spPr>
-        <p:txBody>
-          <a:bodyPr wrap="square" lIns="0" rIns="0" tIns="0" bIns="0" anchor="t">
-            <a:spAutoFit/>
-          </a:bodyPr>
-          <a:lstStyle/>
-          <a:p>
-            <a:pPr algn="l">
-              <a:lnSpc>
-                <a:spcPct val="120000"/>
-              </a:lnSpc>
-            </a:pPr>
-            <a:r>
-              <a:rPr sz="1800" b="0" i="0">
-                <a:solidFill>
-                  <a:srgbClr val="333130"/>
-                </a:solidFill>
-                <a:latin typeface="Source Sans 3"/>
-              </a:rPr>
-              <a:t>Carla Portugal</a:t>
-            </a:r>
-          </a:p>
-        </p:txBody>
-      </p:sp>
-      <p:pic>
-        <p:nvPicPr>
-          <p:cNvPr id="81" name="Picture 80" descr="3861038975520163185.jpg"/>
-          <p:cNvPicPr>
-            <a:picLocks noChangeAspect="1"/>
-          </p:cNvPicPr>
-          <p:nvPr/>
-        </p:nvPicPr>
-        <p:blipFill>
-          <a:blip r:embed="rId9"/>
-          <a:stretch>
-            <a:fillRect/>
-          </a:stretch>
-        </p:blipFill>
-        <p:spPr>
-          <a:xfrm>
-            <a:off x="7458075" y="4381500"/>
-            <a:ext cx="2143125" cy="2143125"/>
-          </a:xfrm>
-          <a:prstGeom prst="rect">
-            <a:avLst/>
-          </a:prstGeom>
-        </p:spPr>
-      </p:pic>
-      <p:sp>
-        <p:nvSpPr>
-          <p:cNvPr id="82" name="TextBox 81"/>
-          <p:cNvSpPr txBox="1"/>
-          <p:nvPr/>
-        </p:nvSpPr>
-        <p:spPr>
-          <a:xfrm>
-            <a:off x="7458075" y="6581775"/>
-            <a:ext cx="2143125" cy="285750"/>
-          </a:xfrm>
-          <a:prstGeom prst="rect">
-            <a:avLst/>
-          </a:prstGeom>
-          <a:noFill/>
-        </p:spPr>
-        <p:txBody>
-          <a:bodyPr wrap="square" lIns="0" rIns="0" tIns="0" bIns="0" anchor="t">
-            <a:spAutoFit/>
-          </a:bodyPr>
-          <a:lstStyle/>
-          <a:p>
-            <a:pPr algn="l">
-              <a:lnSpc>
-                <a:spcPct val="120000"/>
-              </a:lnSpc>
-            </a:pPr>
-            <a:r>
-              <a:rPr sz="1800" b="0" i="0">
-                <a:solidFill>
-                  <a:srgbClr val="333130"/>
-                </a:solidFill>
-                <a:latin typeface="Source Sans 3"/>
-              </a:rPr>
-              <a:t>Gerald Ramírez</a:t>
-            </a:r>
-          </a:p>
-        </p:txBody>
-      </p:sp>
-      <p:pic>
-        <p:nvPicPr>
-          <p:cNvPr id="83" name="Picture 82" descr="118077776354024886.jpg"/>
-          <p:cNvPicPr>
-            <a:picLocks noChangeAspect="1"/>
-          </p:cNvPicPr>
-          <p:nvPr/>
-        </p:nvPicPr>
-        <p:blipFill>
-          <a:blip r:embed="rId10"/>
-          <a:stretch>
-            <a:fillRect/>
-          </a:stretch>
-        </p:blipFill>
-        <p:spPr>
-          <a:xfrm>
-            <a:off x="685800" y="7000875"/>
-            <a:ext cx="2143125" cy="2143125"/>
-          </a:xfrm>
-          <a:prstGeom prst="rect">
-            <a:avLst/>
-          </a:prstGeom>
-        </p:spPr>
-      </p:pic>
-      <p:sp>
-        <p:nvSpPr>
-          <p:cNvPr id="84" name="TextBox 83"/>
-          <p:cNvSpPr txBox="1"/>
-          <p:nvPr/>
-        </p:nvSpPr>
-        <p:spPr>
-          <a:xfrm>
-            <a:off x="685800" y="9201150"/>
-            <a:ext cx="2143125" cy="285750"/>
-          </a:xfrm>
-          <a:prstGeom prst="rect">
-            <a:avLst/>
-          </a:prstGeom>
-          <a:noFill/>
-        </p:spPr>
-        <p:txBody>
-          <a:bodyPr wrap="square" lIns="0" rIns="0" tIns="0" bIns="0" anchor="t">
-            <a:spAutoFit/>
-          </a:bodyPr>
-          <a:lstStyle/>
-          <a:p>
-            <a:pPr algn="l">
-              <a:lnSpc>
-                <a:spcPct val="120000"/>
-              </a:lnSpc>
-            </a:pPr>
-            <a:r>
-              <a:rPr sz="1800" b="0" i="0">
-                <a:solidFill>
-                  <a:srgbClr val="333130"/>
-                </a:solidFill>
-                <a:latin typeface="Source Sans 3"/>
-              </a:rPr>
-              <a:t>Wesley Sander</a:t>
-            </a:r>
-          </a:p>
-        </p:txBody>
-      </p:sp>
-      <p:pic>
-        <p:nvPicPr>
-          <p:cNvPr id="85" name="Picture 84" descr="3794067675830285380.jpg"/>
-          <p:cNvPicPr>
-            <a:picLocks noChangeAspect="1"/>
-          </p:cNvPicPr>
-          <p:nvPr/>
-        </p:nvPicPr>
-        <p:blipFill>
-          <a:blip r:embed="rId11"/>
-          <a:stretch>
-            <a:fillRect/>
-          </a:stretch>
-        </p:blipFill>
-        <p:spPr>
-          <a:xfrm>
-            <a:off x="2943225" y="7000875"/>
-            <a:ext cx="2143125" cy="2143125"/>
-          </a:xfrm>
-          <a:prstGeom prst="rect">
-            <a:avLst/>
-          </a:prstGeom>
-        </p:spPr>
-      </p:pic>
-      <p:sp>
-        <p:nvSpPr>
-          <p:cNvPr id="86" name="TextBox 85"/>
-          <p:cNvSpPr txBox="1"/>
-          <p:nvPr/>
-        </p:nvSpPr>
-        <p:spPr>
-          <a:xfrm>
-            <a:off x="2943225" y="9201150"/>
-            <a:ext cx="2143125" cy="285750"/>
-          </a:xfrm>
-          <a:prstGeom prst="rect">
-            <a:avLst/>
-          </a:prstGeom>
-          <a:noFill/>
-        </p:spPr>
-        <p:txBody>
-          <a:bodyPr wrap="square" lIns="0" rIns="0" tIns="0" bIns="0" anchor="t">
-            <a:spAutoFit/>
-          </a:bodyPr>
-          <a:lstStyle/>
-          <a:p>
-            <a:pPr algn="l">
-              <a:lnSpc>
-                <a:spcPct val="120000"/>
-              </a:lnSpc>
-            </a:pPr>
-            <a:r>
-              <a:rPr sz="1800" b="0" i="0">
-                <a:solidFill>
-                  <a:srgbClr val="333130"/>
-                </a:solidFill>
-                <a:latin typeface="Source Sans 3"/>
-              </a:rPr>
-              <a:t>Isadora Shmidt</a:t>
-            </a:r>
-          </a:p>
-        </p:txBody>
-      </p:sp>
-      <p:pic>
-        <p:nvPicPr>
-          <p:cNvPr id="87" name="Picture 86" descr="6147693292793088277.jpg"/>
-          <p:cNvPicPr>
-            <a:picLocks noChangeAspect="1"/>
-          </p:cNvPicPr>
-          <p:nvPr/>
-        </p:nvPicPr>
-        <p:blipFill>
-          <a:blip r:embed="rId12"/>
-          <a:stretch>
-            <a:fillRect/>
-          </a:stretch>
-        </p:blipFill>
-        <p:spPr>
-          <a:xfrm>
-            <a:off x="5200650" y="7000875"/>
-            <a:ext cx="2143125" cy="2143125"/>
-          </a:xfrm>
-          <a:prstGeom prst="rect">
-            <a:avLst/>
-          </a:prstGeom>
-        </p:spPr>
-      </p:pic>
-      <p:sp>
-        <p:nvSpPr>
-          <p:cNvPr id="88" name="TextBox 87"/>
-          <p:cNvSpPr txBox="1"/>
-          <p:nvPr/>
-        </p:nvSpPr>
-        <p:spPr>
-          <a:xfrm>
-            <a:off x="5200650" y="9201150"/>
-            <a:ext cx="2143125" cy="285750"/>
-          </a:xfrm>
-          <a:prstGeom prst="rect">
-            <a:avLst/>
-          </a:prstGeom>
-          <a:noFill/>
-        </p:spPr>
-        <p:txBody>
-          <a:bodyPr wrap="square" lIns="0" rIns="0" tIns="0" bIns="0" anchor="t">
-            <a:spAutoFit/>
-          </a:bodyPr>
-          <a:lstStyle/>
-          <a:p>
-            <a:pPr algn="l">
-              <a:lnSpc>
-                <a:spcPct val="120000"/>
-              </a:lnSpc>
-            </a:pPr>
-            <a:r>
-              <a:rPr sz="1800" b="0" i="0">
-                <a:solidFill>
-                  <a:srgbClr val="333130"/>
-                </a:solidFill>
-                <a:latin typeface="Source Sans 3"/>
-              </a:rPr>
-              <a:t>Delvin Solkinson</a:t>
-            </a:r>
-          </a:p>
-        </p:txBody>
-      </p:sp>
-      <p:pic>
-        <p:nvPicPr>
-          <p:cNvPr id="89" name="Picture 88" descr="2935605721114179229.jpg"/>
+          <p:cNvPr id="89" name="Picture 88" descr="931803531823155755.jpg"/>
           <p:cNvPicPr>
             <a:picLocks noChangeAspect="1"/>
           </p:cNvPicPr>
@@ -8675,7 +8675,7 @@
       </p:sp>
       <p:pic>
         <p:nvPicPr>
-          <p:cNvPr id="91" name="Picture 90" descr="8903105856644367317.jpg"/>
+          <p:cNvPr id="91" name="Picture 90" descr="5248280226730105287.jpg"/>
           <p:cNvPicPr>
             <a:picLocks noChangeAspect="1"/>
           </p:cNvPicPr>
@@ -8738,7 +8738,7 @@
       </p:sp>
       <p:pic>
         <p:nvPicPr>
-          <p:cNvPr id="93" name="Picture 92" descr="5986580262004156277.jpg"/>
+          <p:cNvPr id="93" name="Picture 92" descr="6818123601560314859.jpg"/>
           <p:cNvPicPr>
             <a:picLocks noChangeAspect="1"/>
           </p:cNvPicPr>
@@ -8801,7 +8801,7 @@
       </p:sp>
       <p:pic>
         <p:nvPicPr>
-          <p:cNvPr id="95" name="Picture 94" descr="4642587556195066875.jpg"/>
+          <p:cNvPr id="95" name="Picture 94" descr="6898878685590571014.jpg"/>
           <p:cNvPicPr>
             <a:picLocks noChangeAspect="1"/>
           </p:cNvPicPr>
@@ -8864,7 +8864,7 @@
       </p:sp>
       <p:pic>
         <p:nvPicPr>
-          <p:cNvPr id="97" name="Picture 96" descr="7462634439622850092.jpg"/>
+          <p:cNvPr id="97" name="Picture 96" descr="7715151042430390727.jpg"/>
           <p:cNvPicPr>
             <a:picLocks noChangeAspect="1"/>
           </p:cNvPicPr>
@@ -13338,7 +13338,7 @@
       </p:pic>
       <p:pic>
         <p:nvPicPr>
-          <p:cNvPr id="71" name="Picture 70" descr="8694088384298960110.jpg"/>
+          <p:cNvPr id="71" name="Picture 70" descr="3121827617327194404.jpg"/>
           <p:cNvPicPr>
             <a:picLocks noChangeAspect="1"/>
           </p:cNvPicPr>
@@ -13401,7 +13401,7 @@
       </p:sp>
       <p:pic>
         <p:nvPicPr>
-          <p:cNvPr id="73" name="Picture 72" descr="3139326610849488932.jpg"/>
+          <p:cNvPr id="73" name="Picture 72" descr="2809537841490521723.jpg"/>
           <p:cNvPicPr>
             <a:picLocks noChangeAspect="1"/>
           </p:cNvPicPr>
@@ -13432,6 +13432,447 @@
         <p:spPr>
           <a:xfrm>
             <a:off x="7458075" y="3962400"/>
+            <a:ext cx="2143125" cy="285750"/>
+          </a:xfrm>
+          <a:prstGeom prst="rect">
+            <a:avLst/>
+          </a:prstGeom>
+          <a:noFill/>
+        </p:spPr>
+        <p:txBody>
+          <a:bodyPr wrap="square" lIns="0" rIns="0" tIns="0" bIns="0" anchor="t">
+            <a:spAutoFit/>
+          </a:bodyPr>
+          <a:lstStyle/>
+          <a:p>
+            <a:pPr algn="l">
+              <a:lnSpc>
+                <a:spcPct val="120000"/>
+              </a:lnSpc>
+            </a:pPr>
+            <a:r>
+              <a:rPr sz="1800" b="0" i="0">
+                <a:solidFill>
+                  <a:srgbClr val="333130"/>
+                </a:solidFill>
+                <a:latin typeface="Source Sans 3"/>
+              </a:rPr>
+              <a:t>Brian Daubenspeck</a:t>
+            </a:r>
+          </a:p>
+        </p:txBody>
+      </p:sp>
+      <p:pic>
+        <p:nvPicPr>
+          <p:cNvPr id="75" name="Picture 74" descr="5232482427252906244.jpg"/>
+          <p:cNvPicPr>
+            <a:picLocks noChangeAspect="1"/>
+          </p:cNvPicPr>
+          <p:nvPr/>
+        </p:nvPicPr>
+        <p:blipFill>
+          <a:blip r:embed="rId6"/>
+          <a:stretch>
+            <a:fillRect/>
+          </a:stretch>
+        </p:blipFill>
+        <p:spPr>
+          <a:xfrm>
+            <a:off x="685800" y="4381500"/>
+            <a:ext cx="2143125" cy="2143125"/>
+          </a:xfrm>
+          <a:prstGeom prst="rect">
+            <a:avLst/>
+          </a:prstGeom>
+        </p:spPr>
+      </p:pic>
+      <p:sp>
+        <p:nvSpPr>
+          <p:cNvPr id="76" name="TextBox 75"/>
+          <p:cNvSpPr txBox="1"/>
+          <p:nvPr/>
+        </p:nvSpPr>
+        <p:spPr>
+          <a:xfrm>
+            <a:off x="685800" y="6581775"/>
+            <a:ext cx="2143125" cy="285750"/>
+          </a:xfrm>
+          <a:prstGeom prst="rect">
+            <a:avLst/>
+          </a:prstGeom>
+          <a:noFill/>
+        </p:spPr>
+        <p:txBody>
+          <a:bodyPr wrap="square" lIns="0" rIns="0" tIns="0" bIns="0" anchor="t">
+            <a:spAutoFit/>
+          </a:bodyPr>
+          <a:lstStyle/>
+          <a:p>
+            <a:pPr algn="l">
+              <a:lnSpc>
+                <a:spcPct val="120000"/>
+              </a:lnSpc>
+            </a:pPr>
+            <a:r>
+              <a:rPr sz="1800" b="0" i="0">
+                <a:solidFill>
+                  <a:srgbClr val="333130"/>
+                </a:solidFill>
+                <a:latin typeface="Source Sans 3"/>
+              </a:rPr>
+              <a:t>Isadora Shmidt</a:t>
+            </a:r>
+          </a:p>
+        </p:txBody>
+      </p:sp>
+      <p:pic>
+        <p:nvPicPr>
+          <p:cNvPr id="77" name="Picture 76" descr="2935389191544078019.jpg"/>
+          <p:cNvPicPr>
+            <a:picLocks noChangeAspect="1"/>
+          </p:cNvPicPr>
+          <p:nvPr/>
+        </p:nvPicPr>
+        <p:blipFill>
+          <a:blip r:embed="rId7"/>
+          <a:stretch>
+            <a:fillRect/>
+          </a:stretch>
+        </p:blipFill>
+        <p:spPr>
+          <a:xfrm>
+            <a:off x="2943225" y="4381500"/>
+            <a:ext cx="2143125" cy="2143125"/>
+          </a:xfrm>
+          <a:prstGeom prst="rect">
+            <a:avLst/>
+          </a:prstGeom>
+        </p:spPr>
+      </p:pic>
+      <p:sp>
+        <p:nvSpPr>
+          <p:cNvPr id="78" name="TextBox 77"/>
+          <p:cNvSpPr txBox="1"/>
+          <p:nvPr/>
+        </p:nvSpPr>
+        <p:spPr>
+          <a:xfrm>
+            <a:off x="2943225" y="6581775"/>
+            <a:ext cx="2143125" cy="285750"/>
+          </a:xfrm>
+          <a:prstGeom prst="rect">
+            <a:avLst/>
+          </a:prstGeom>
+          <a:noFill/>
+        </p:spPr>
+        <p:txBody>
+          <a:bodyPr wrap="square" lIns="0" rIns="0" tIns="0" bIns="0" anchor="t">
+            <a:spAutoFit/>
+          </a:bodyPr>
+          <a:lstStyle/>
+          <a:p>
+            <a:pPr algn="l">
+              <a:lnSpc>
+                <a:spcPct val="120000"/>
+              </a:lnSpc>
+            </a:pPr>
+            <a:r>
+              <a:rPr sz="1800" b="0" i="0">
+                <a:solidFill>
+                  <a:srgbClr val="333130"/>
+                </a:solidFill>
+                <a:latin typeface="Source Sans 3"/>
+              </a:rPr>
+              <a:t>Gerald Ramírez</a:t>
+            </a:r>
+          </a:p>
+        </p:txBody>
+      </p:sp>
+      <p:pic>
+        <p:nvPicPr>
+          <p:cNvPr id="79" name="Picture 78" descr="6898878685590571014.jpg"/>
+          <p:cNvPicPr>
+            <a:picLocks noChangeAspect="1"/>
+          </p:cNvPicPr>
+          <p:nvPr/>
+        </p:nvPicPr>
+        <p:blipFill>
+          <a:blip r:embed="rId8"/>
+          <a:stretch>
+            <a:fillRect/>
+          </a:stretch>
+        </p:blipFill>
+        <p:spPr>
+          <a:xfrm>
+            <a:off x="5200650" y="4381500"/>
+            <a:ext cx="2143125" cy="2143125"/>
+          </a:xfrm>
+          <a:prstGeom prst="rect">
+            <a:avLst/>
+          </a:prstGeom>
+        </p:spPr>
+      </p:pic>
+      <p:sp>
+        <p:nvSpPr>
+          <p:cNvPr id="80" name="TextBox 79"/>
+          <p:cNvSpPr txBox="1"/>
+          <p:nvPr/>
+        </p:nvSpPr>
+        <p:spPr>
+          <a:xfrm>
+            <a:off x="5200650" y="6581775"/>
+            <a:ext cx="2143125" cy="285750"/>
+          </a:xfrm>
+          <a:prstGeom prst="rect">
+            <a:avLst/>
+          </a:prstGeom>
+          <a:noFill/>
+        </p:spPr>
+        <p:txBody>
+          <a:bodyPr wrap="square" lIns="0" rIns="0" tIns="0" bIns="0" anchor="t">
+            <a:spAutoFit/>
+          </a:bodyPr>
+          <a:lstStyle/>
+          <a:p>
+            <a:pPr algn="l">
+              <a:lnSpc>
+                <a:spcPct val="120000"/>
+              </a:lnSpc>
+            </a:pPr>
+            <a:r>
+              <a:rPr sz="1800" b="0" i="0">
+                <a:solidFill>
+                  <a:srgbClr val="333130"/>
+                </a:solidFill>
+                <a:latin typeface="Source Sans 3"/>
+              </a:rPr>
+              <a:t>Loida Vasquez</a:t>
+            </a:r>
+          </a:p>
+        </p:txBody>
+      </p:sp>
+      <p:pic>
+        <p:nvPicPr>
+          <p:cNvPr id="81" name="Picture 80" descr="2459370116124079744.jpg"/>
+          <p:cNvPicPr>
+            <a:picLocks noChangeAspect="1"/>
+          </p:cNvPicPr>
+          <p:nvPr/>
+        </p:nvPicPr>
+        <p:blipFill>
+          <a:blip r:embed="rId9"/>
+          <a:stretch>
+            <a:fillRect/>
+          </a:stretch>
+        </p:blipFill>
+        <p:spPr>
+          <a:xfrm>
+            <a:off x="7458075" y="4381500"/>
+            <a:ext cx="2143125" cy="2143125"/>
+          </a:xfrm>
+          <a:prstGeom prst="rect">
+            <a:avLst/>
+          </a:prstGeom>
+        </p:spPr>
+      </p:pic>
+      <p:sp>
+        <p:nvSpPr>
+          <p:cNvPr id="82" name="TextBox 81"/>
+          <p:cNvSpPr txBox="1"/>
+          <p:nvPr/>
+        </p:nvSpPr>
+        <p:spPr>
+          <a:xfrm>
+            <a:off x="7458075" y="6581775"/>
+            <a:ext cx="2143125" cy="285750"/>
+          </a:xfrm>
+          <a:prstGeom prst="rect">
+            <a:avLst/>
+          </a:prstGeom>
+          <a:noFill/>
+        </p:spPr>
+        <p:txBody>
+          <a:bodyPr wrap="square" lIns="0" rIns="0" tIns="0" bIns="0" anchor="t">
+            <a:spAutoFit/>
+          </a:bodyPr>
+          <a:lstStyle/>
+          <a:p>
+            <a:pPr algn="l">
+              <a:lnSpc>
+                <a:spcPct val="120000"/>
+              </a:lnSpc>
+            </a:pPr>
+            <a:r>
+              <a:rPr sz="1800" b="0" i="0">
+                <a:solidFill>
+                  <a:srgbClr val="333130"/>
+                </a:solidFill>
+                <a:latin typeface="Source Sans 3"/>
+              </a:rPr>
+              <a:t>Wesley Sander</a:t>
+            </a:r>
+          </a:p>
+        </p:txBody>
+      </p:sp>
+      <p:pic>
+        <p:nvPicPr>
+          <p:cNvPr id="83" name="Picture 82" descr="8537488814558054651.jpg"/>
+          <p:cNvPicPr>
+            <a:picLocks noChangeAspect="1"/>
+          </p:cNvPicPr>
+          <p:nvPr/>
+        </p:nvPicPr>
+        <p:blipFill>
+          <a:blip r:embed="rId10"/>
+          <a:stretch>
+            <a:fillRect/>
+          </a:stretch>
+        </p:blipFill>
+        <p:spPr>
+          <a:xfrm>
+            <a:off x="685800" y="7000875"/>
+            <a:ext cx="2143125" cy="2143125"/>
+          </a:xfrm>
+          <a:prstGeom prst="rect">
+            <a:avLst/>
+          </a:prstGeom>
+        </p:spPr>
+      </p:pic>
+      <p:sp>
+        <p:nvSpPr>
+          <p:cNvPr id="84" name="TextBox 83"/>
+          <p:cNvSpPr txBox="1"/>
+          <p:nvPr/>
+        </p:nvSpPr>
+        <p:spPr>
+          <a:xfrm>
+            <a:off x="685800" y="9201150"/>
+            <a:ext cx="2143125" cy="285750"/>
+          </a:xfrm>
+          <a:prstGeom prst="rect">
+            <a:avLst/>
+          </a:prstGeom>
+          <a:noFill/>
+        </p:spPr>
+        <p:txBody>
+          <a:bodyPr wrap="square" lIns="0" rIns="0" tIns="0" bIns="0" anchor="t">
+            <a:spAutoFit/>
+          </a:bodyPr>
+          <a:lstStyle/>
+          <a:p>
+            <a:pPr algn="l">
+              <a:lnSpc>
+                <a:spcPct val="120000"/>
+              </a:lnSpc>
+            </a:pPr>
+            <a:r>
+              <a:rPr sz="1800" b="0" i="0">
+                <a:solidFill>
+                  <a:srgbClr val="333130"/>
+                </a:solidFill>
+                <a:latin typeface="Source Sans 3"/>
+              </a:rPr>
+              <a:t>Elena Kalli</a:t>
+            </a:r>
+          </a:p>
+        </p:txBody>
+      </p:sp>
+      <p:pic>
+        <p:nvPicPr>
+          <p:cNvPr id="85" name="Picture 84" descr="931803531823155755.jpg"/>
+          <p:cNvPicPr>
+            <a:picLocks noChangeAspect="1"/>
+          </p:cNvPicPr>
+          <p:nvPr/>
+        </p:nvPicPr>
+        <p:blipFill>
+          <a:blip r:embed="rId11"/>
+          <a:stretch>
+            <a:fillRect/>
+          </a:stretch>
+        </p:blipFill>
+        <p:spPr>
+          <a:xfrm>
+            <a:off x="2943225" y="7000875"/>
+            <a:ext cx="2143125" cy="2143125"/>
+          </a:xfrm>
+          <a:prstGeom prst="rect">
+            <a:avLst/>
+          </a:prstGeom>
+        </p:spPr>
+      </p:pic>
+      <p:sp>
+        <p:nvSpPr>
+          <p:cNvPr id="86" name="TextBox 85"/>
+          <p:cNvSpPr txBox="1"/>
+          <p:nvPr/>
+        </p:nvSpPr>
+        <p:spPr>
+          <a:xfrm>
+            <a:off x="2943225" y="9201150"/>
+            <a:ext cx="2143125" cy="285750"/>
+          </a:xfrm>
+          <a:prstGeom prst="rect">
+            <a:avLst/>
+          </a:prstGeom>
+          <a:noFill/>
+        </p:spPr>
+        <p:txBody>
+          <a:bodyPr wrap="square" lIns="0" rIns="0" tIns="0" bIns="0" anchor="t">
+            <a:spAutoFit/>
+          </a:bodyPr>
+          <a:lstStyle/>
+          <a:p>
+            <a:pPr algn="l">
+              <a:lnSpc>
+                <a:spcPct val="120000"/>
+              </a:lnSpc>
+            </a:pPr>
+            <a:r>
+              <a:rPr sz="1800" b="0" i="0">
+                <a:solidFill>
+                  <a:srgbClr val="333130"/>
+                </a:solidFill>
+                <a:latin typeface="Source Sans 3"/>
+              </a:rPr>
+              <a:t>Tommy Tapper</a:t>
+            </a:r>
+          </a:p>
+        </p:txBody>
+      </p:sp>
+      <p:pic>
+        <p:nvPicPr>
+          <p:cNvPr id="87" name="Picture 86" descr="6273480043131842505.jpg"/>
+          <p:cNvPicPr>
+            <a:picLocks noChangeAspect="1"/>
+          </p:cNvPicPr>
+          <p:nvPr/>
+        </p:nvPicPr>
+        <p:blipFill>
+          <a:blip r:embed="rId12"/>
+          <a:stretch>
+            <a:fillRect/>
+          </a:stretch>
+        </p:blipFill>
+        <p:spPr>
+          <a:xfrm>
+            <a:off x="5200650" y="7000875"/>
+            <a:ext cx="2143125" cy="2143125"/>
+          </a:xfrm>
+          <a:prstGeom prst="rect">
+            <a:avLst/>
+          </a:prstGeom>
+        </p:spPr>
+      </p:pic>
+      <p:sp>
+        <p:nvSpPr>
+          <p:cNvPr id="88" name="TextBox 87"/>
+          <p:cNvSpPr txBox="1"/>
+          <p:nvPr/>
+        </p:nvSpPr>
+        <p:spPr>
+          <a:xfrm>
+            <a:off x="5200650" y="9201150"/>
             <a:ext cx="2143125" cy="285750"/>
           </a:xfrm>
           <a:prstGeom prst="rect">
@@ -13464,448 +13905,7 @@
       </p:sp>
       <p:pic>
         <p:nvPicPr>
-          <p:cNvPr id="75" name="Picture 74" descr="3794067675830285380.jpg"/>
-          <p:cNvPicPr>
-            <a:picLocks noChangeAspect="1"/>
-          </p:cNvPicPr>
-          <p:nvPr/>
-        </p:nvPicPr>
-        <p:blipFill>
-          <a:blip r:embed="rId6"/>
-          <a:stretch>
-            <a:fillRect/>
-          </a:stretch>
-        </p:blipFill>
-        <p:spPr>
-          <a:xfrm>
-            <a:off x="685800" y="4381500"/>
-            <a:ext cx="2143125" cy="2143125"/>
-          </a:xfrm>
-          <a:prstGeom prst="rect">
-            <a:avLst/>
-          </a:prstGeom>
-        </p:spPr>
-      </p:pic>
-      <p:sp>
-        <p:nvSpPr>
-          <p:cNvPr id="76" name="TextBox 75"/>
-          <p:cNvSpPr txBox="1"/>
-          <p:nvPr/>
-        </p:nvSpPr>
-        <p:spPr>
-          <a:xfrm>
-            <a:off x="685800" y="6581775"/>
-            <a:ext cx="2143125" cy="285750"/>
-          </a:xfrm>
-          <a:prstGeom prst="rect">
-            <a:avLst/>
-          </a:prstGeom>
-          <a:noFill/>
-        </p:spPr>
-        <p:txBody>
-          <a:bodyPr wrap="square" lIns="0" rIns="0" tIns="0" bIns="0" anchor="t">
-            <a:spAutoFit/>
-          </a:bodyPr>
-          <a:lstStyle/>
-          <a:p>
-            <a:pPr algn="l">
-              <a:lnSpc>
-                <a:spcPct val="120000"/>
-              </a:lnSpc>
-            </a:pPr>
-            <a:r>
-              <a:rPr sz="1800" b="0" i="0">
-                <a:solidFill>
-                  <a:srgbClr val="333130"/>
-                </a:solidFill>
-                <a:latin typeface="Source Sans 3"/>
-              </a:rPr>
-              <a:t>Isadora Shmidt</a:t>
-            </a:r>
-          </a:p>
-        </p:txBody>
-      </p:sp>
-      <p:pic>
-        <p:nvPicPr>
-          <p:cNvPr id="77" name="Picture 76" descr="3861038975520163185.jpg"/>
-          <p:cNvPicPr>
-            <a:picLocks noChangeAspect="1"/>
-          </p:cNvPicPr>
-          <p:nvPr/>
-        </p:nvPicPr>
-        <p:blipFill>
-          <a:blip r:embed="rId7"/>
-          <a:stretch>
-            <a:fillRect/>
-          </a:stretch>
-        </p:blipFill>
-        <p:spPr>
-          <a:xfrm>
-            <a:off x="2943225" y="4381500"/>
-            <a:ext cx="2143125" cy="2143125"/>
-          </a:xfrm>
-          <a:prstGeom prst="rect">
-            <a:avLst/>
-          </a:prstGeom>
-        </p:spPr>
-      </p:pic>
-      <p:sp>
-        <p:nvSpPr>
-          <p:cNvPr id="78" name="TextBox 77"/>
-          <p:cNvSpPr txBox="1"/>
-          <p:nvPr/>
-        </p:nvSpPr>
-        <p:spPr>
-          <a:xfrm>
-            <a:off x="2943225" y="6581775"/>
-            <a:ext cx="2143125" cy="285750"/>
-          </a:xfrm>
-          <a:prstGeom prst="rect">
-            <a:avLst/>
-          </a:prstGeom>
-          <a:noFill/>
-        </p:spPr>
-        <p:txBody>
-          <a:bodyPr wrap="square" lIns="0" rIns="0" tIns="0" bIns="0" anchor="t">
-            <a:spAutoFit/>
-          </a:bodyPr>
-          <a:lstStyle/>
-          <a:p>
-            <a:pPr algn="l">
-              <a:lnSpc>
-                <a:spcPct val="120000"/>
-              </a:lnSpc>
-            </a:pPr>
-            <a:r>
-              <a:rPr sz="1800" b="0" i="0">
-                <a:solidFill>
-                  <a:srgbClr val="333130"/>
-                </a:solidFill>
-                <a:latin typeface="Source Sans 3"/>
-              </a:rPr>
-              <a:t>Gerald Ramírez</a:t>
-            </a:r>
-          </a:p>
-        </p:txBody>
-      </p:sp>
-      <p:pic>
-        <p:nvPicPr>
-          <p:cNvPr id="79" name="Picture 78" descr="4642587556195066875.jpg"/>
-          <p:cNvPicPr>
-            <a:picLocks noChangeAspect="1"/>
-          </p:cNvPicPr>
-          <p:nvPr/>
-        </p:nvPicPr>
-        <p:blipFill>
-          <a:blip r:embed="rId8"/>
-          <a:stretch>
-            <a:fillRect/>
-          </a:stretch>
-        </p:blipFill>
-        <p:spPr>
-          <a:xfrm>
-            <a:off x="5200650" y="4381500"/>
-            <a:ext cx="2143125" cy="2143125"/>
-          </a:xfrm>
-          <a:prstGeom prst="rect">
-            <a:avLst/>
-          </a:prstGeom>
-        </p:spPr>
-      </p:pic>
-      <p:sp>
-        <p:nvSpPr>
-          <p:cNvPr id="80" name="TextBox 79"/>
-          <p:cNvSpPr txBox="1"/>
-          <p:nvPr/>
-        </p:nvSpPr>
-        <p:spPr>
-          <a:xfrm>
-            <a:off x="5200650" y="6581775"/>
-            <a:ext cx="2143125" cy="285750"/>
-          </a:xfrm>
-          <a:prstGeom prst="rect">
-            <a:avLst/>
-          </a:prstGeom>
-          <a:noFill/>
-        </p:spPr>
-        <p:txBody>
-          <a:bodyPr wrap="square" lIns="0" rIns="0" tIns="0" bIns="0" anchor="t">
-            <a:spAutoFit/>
-          </a:bodyPr>
-          <a:lstStyle/>
-          <a:p>
-            <a:pPr algn="l">
-              <a:lnSpc>
-                <a:spcPct val="120000"/>
-              </a:lnSpc>
-            </a:pPr>
-            <a:r>
-              <a:rPr sz="1800" b="0" i="0">
-                <a:solidFill>
-                  <a:srgbClr val="333130"/>
-                </a:solidFill>
-                <a:latin typeface="Source Sans 3"/>
-              </a:rPr>
-              <a:t>Loida Vasquez</a:t>
-            </a:r>
-          </a:p>
-        </p:txBody>
-      </p:sp>
-      <p:pic>
-        <p:nvPicPr>
-          <p:cNvPr id="81" name="Picture 80" descr="118077776354024886.jpg"/>
-          <p:cNvPicPr>
-            <a:picLocks noChangeAspect="1"/>
-          </p:cNvPicPr>
-          <p:nvPr/>
-        </p:nvPicPr>
-        <p:blipFill>
-          <a:blip r:embed="rId9"/>
-          <a:stretch>
-            <a:fillRect/>
-          </a:stretch>
-        </p:blipFill>
-        <p:spPr>
-          <a:xfrm>
-            <a:off x="7458075" y="4381500"/>
-            <a:ext cx="2143125" cy="2143125"/>
-          </a:xfrm>
-          <a:prstGeom prst="rect">
-            <a:avLst/>
-          </a:prstGeom>
-        </p:spPr>
-      </p:pic>
-      <p:sp>
-        <p:nvSpPr>
-          <p:cNvPr id="82" name="TextBox 81"/>
-          <p:cNvSpPr txBox="1"/>
-          <p:nvPr/>
-        </p:nvSpPr>
-        <p:spPr>
-          <a:xfrm>
-            <a:off x="7458075" y="6581775"/>
-            <a:ext cx="2143125" cy="285750"/>
-          </a:xfrm>
-          <a:prstGeom prst="rect">
-            <a:avLst/>
-          </a:prstGeom>
-          <a:noFill/>
-        </p:spPr>
-        <p:txBody>
-          <a:bodyPr wrap="square" lIns="0" rIns="0" tIns="0" bIns="0" anchor="t">
-            <a:spAutoFit/>
-          </a:bodyPr>
-          <a:lstStyle/>
-          <a:p>
-            <a:pPr algn="l">
-              <a:lnSpc>
-                <a:spcPct val="120000"/>
-              </a:lnSpc>
-            </a:pPr>
-            <a:r>
-              <a:rPr sz="1800" b="0" i="0">
-                <a:solidFill>
-                  <a:srgbClr val="333130"/>
-                </a:solidFill>
-                <a:latin typeface="Source Sans 3"/>
-              </a:rPr>
-              <a:t>Wesley Sander</a:t>
-            </a:r>
-          </a:p>
-        </p:txBody>
-      </p:sp>
-      <p:pic>
-        <p:nvPicPr>
-          <p:cNvPr id="83" name="Picture 82" descr="2750903348445113879.jpg"/>
-          <p:cNvPicPr>
-            <a:picLocks noChangeAspect="1"/>
-          </p:cNvPicPr>
-          <p:nvPr/>
-        </p:nvPicPr>
-        <p:blipFill>
-          <a:blip r:embed="rId10"/>
-          <a:stretch>
-            <a:fillRect/>
-          </a:stretch>
-        </p:blipFill>
-        <p:spPr>
-          <a:xfrm>
-            <a:off x="685800" y="7000875"/>
-            <a:ext cx="2143125" cy="2143125"/>
-          </a:xfrm>
-          <a:prstGeom prst="rect">
-            <a:avLst/>
-          </a:prstGeom>
-        </p:spPr>
-      </p:pic>
-      <p:sp>
-        <p:nvSpPr>
-          <p:cNvPr id="84" name="TextBox 83"/>
-          <p:cNvSpPr txBox="1"/>
-          <p:nvPr/>
-        </p:nvSpPr>
-        <p:spPr>
-          <a:xfrm>
-            <a:off x="685800" y="9201150"/>
-            <a:ext cx="2143125" cy="285750"/>
-          </a:xfrm>
-          <a:prstGeom prst="rect">
-            <a:avLst/>
-          </a:prstGeom>
-          <a:noFill/>
-        </p:spPr>
-        <p:txBody>
-          <a:bodyPr wrap="square" lIns="0" rIns="0" tIns="0" bIns="0" anchor="t">
-            <a:spAutoFit/>
-          </a:bodyPr>
-          <a:lstStyle/>
-          <a:p>
-            <a:pPr algn="l">
-              <a:lnSpc>
-                <a:spcPct val="120000"/>
-              </a:lnSpc>
-            </a:pPr>
-            <a:r>
-              <a:rPr sz="1800" b="0" i="0">
-                <a:solidFill>
-                  <a:srgbClr val="333130"/>
-                </a:solidFill>
-                <a:latin typeface="Source Sans 3"/>
-              </a:rPr>
-              <a:t>Elena Kalli</a:t>
-            </a:r>
-          </a:p>
-        </p:txBody>
-      </p:sp>
-      <p:pic>
-        <p:nvPicPr>
-          <p:cNvPr id="85" name="Picture 84" descr="2935605721114179229.jpg"/>
-          <p:cNvPicPr>
-            <a:picLocks noChangeAspect="1"/>
-          </p:cNvPicPr>
-          <p:nvPr/>
-        </p:nvPicPr>
-        <p:blipFill>
-          <a:blip r:embed="rId11"/>
-          <a:stretch>
-            <a:fillRect/>
-          </a:stretch>
-        </p:blipFill>
-        <p:spPr>
-          <a:xfrm>
-            <a:off x="2943225" y="7000875"/>
-            <a:ext cx="2143125" cy="2143125"/>
-          </a:xfrm>
-          <a:prstGeom prst="rect">
-            <a:avLst/>
-          </a:prstGeom>
-        </p:spPr>
-      </p:pic>
-      <p:sp>
-        <p:nvSpPr>
-          <p:cNvPr id="86" name="TextBox 85"/>
-          <p:cNvSpPr txBox="1"/>
-          <p:nvPr/>
-        </p:nvSpPr>
-        <p:spPr>
-          <a:xfrm>
-            <a:off x="2943225" y="9201150"/>
-            <a:ext cx="2143125" cy="285750"/>
-          </a:xfrm>
-          <a:prstGeom prst="rect">
-            <a:avLst/>
-          </a:prstGeom>
-          <a:noFill/>
-        </p:spPr>
-        <p:txBody>
-          <a:bodyPr wrap="square" lIns="0" rIns="0" tIns="0" bIns="0" anchor="t">
-            <a:spAutoFit/>
-          </a:bodyPr>
-          <a:lstStyle/>
-          <a:p>
-            <a:pPr algn="l">
-              <a:lnSpc>
-                <a:spcPct val="120000"/>
-              </a:lnSpc>
-            </a:pPr>
-            <a:r>
-              <a:rPr sz="1800" b="0" i="0">
-                <a:solidFill>
-                  <a:srgbClr val="333130"/>
-                </a:solidFill>
-                <a:latin typeface="Source Sans 3"/>
-              </a:rPr>
-              <a:t>Tommy Tapper</a:t>
-            </a:r>
-          </a:p>
-        </p:txBody>
-      </p:sp>
-      <p:pic>
-        <p:nvPicPr>
-          <p:cNvPr id="87" name="Picture 86" descr="5798608773535107475.jpg"/>
-          <p:cNvPicPr>
-            <a:picLocks noChangeAspect="1"/>
-          </p:cNvPicPr>
-          <p:nvPr/>
-        </p:nvPicPr>
-        <p:blipFill>
-          <a:blip r:embed="rId12"/>
-          <a:stretch>
-            <a:fillRect/>
-          </a:stretch>
-        </p:blipFill>
-        <p:spPr>
-          <a:xfrm>
-            <a:off x="5200650" y="7000875"/>
-            <a:ext cx="2143125" cy="2143125"/>
-          </a:xfrm>
-          <a:prstGeom prst="rect">
-            <a:avLst/>
-          </a:prstGeom>
-        </p:spPr>
-      </p:pic>
-      <p:sp>
-        <p:nvSpPr>
-          <p:cNvPr id="88" name="TextBox 87"/>
-          <p:cNvSpPr txBox="1"/>
-          <p:nvPr/>
-        </p:nvSpPr>
-        <p:spPr>
-          <a:xfrm>
-            <a:off x="5200650" y="9201150"/>
-            <a:ext cx="2143125" cy="285750"/>
-          </a:xfrm>
-          <a:prstGeom prst="rect">
-            <a:avLst/>
-          </a:prstGeom>
-          <a:noFill/>
-        </p:spPr>
-        <p:txBody>
-          <a:bodyPr wrap="square" lIns="0" rIns="0" tIns="0" bIns="0" anchor="t">
-            <a:spAutoFit/>
-          </a:bodyPr>
-          <a:lstStyle/>
-          <a:p>
-            <a:pPr algn="l">
-              <a:lnSpc>
-                <a:spcPct val="120000"/>
-              </a:lnSpc>
-            </a:pPr>
-            <a:r>
-              <a:rPr sz="1800" b="0" i="0">
-                <a:solidFill>
-                  <a:srgbClr val="333130"/>
-                </a:solidFill>
-                <a:latin typeface="Source Sans 3"/>
-              </a:rPr>
-              <a:t>Brian Daubenspeck</a:t>
-            </a:r>
-          </a:p>
-        </p:txBody>
-      </p:sp>
-      <p:pic>
-        <p:nvPicPr>
-          <p:cNvPr id="89" name="Picture 88" descr="8903105856644367317.jpg"/>
+          <p:cNvPr id="89" name="Picture 88" descr="5248280226730105287.jpg"/>
           <p:cNvPicPr>
             <a:picLocks noChangeAspect="1"/>
           </p:cNvPicPr>
@@ -13968,7 +13968,7 @@
       </p:sp>
       <p:pic>
         <p:nvPicPr>
-          <p:cNvPr id="91" name="Picture 90" descr="6147693292793088277.jpg"/>
+          <p:cNvPr id="91" name="Picture 90" descr="5210732961209071061.jpg"/>
           <p:cNvPicPr>
             <a:picLocks noChangeAspect="1"/>
           </p:cNvPicPr>
@@ -14031,7 +14031,7 @@
       </p:sp>
       <p:pic>
         <p:nvPicPr>
-          <p:cNvPr id="93" name="Picture 92" descr="5986580262004156277.jpg"/>
+          <p:cNvPr id="93" name="Picture 92" descr="6818123601560314859.jpg"/>
           <p:cNvPicPr>
             <a:picLocks noChangeAspect="1"/>
           </p:cNvPicPr>
@@ -14094,7 +14094,7 @@
       </p:sp>
       <p:pic>
         <p:nvPicPr>
-          <p:cNvPr id="95" name="Picture 94" descr="7250826599254344975.jpg"/>
+          <p:cNvPr id="95" name="Picture 94" descr="1871177202792540355.jpg"/>
           <p:cNvPicPr>
             <a:picLocks noChangeAspect="1"/>
           </p:cNvPicPr>
@@ -14157,7 +14157,7 @@
       </p:sp>
       <p:pic>
         <p:nvPicPr>
-          <p:cNvPr id="97" name="Picture 96" descr="7462634439622850092.jpg"/>
+          <p:cNvPr id="97" name="Picture 96" descr="7715151042430390727.jpg"/>
           <p:cNvPicPr>
             <a:picLocks noChangeAspect="1"/>
           </p:cNvPicPr>
@@ -18631,7 +18631,7 @@
       </p:pic>
       <p:pic>
         <p:nvPicPr>
-          <p:cNvPr id="71" name="Picture 70" descr="7462634439622850092.jpg"/>
+          <p:cNvPr id="71" name="Picture 70" descr="7715151042430390727.jpg"/>
           <p:cNvPicPr>
             <a:picLocks noChangeAspect="1"/>
           </p:cNvPicPr>
@@ -18694,7 +18694,7 @@
       </p:sp>
       <p:pic>
         <p:nvPicPr>
-          <p:cNvPr id="73" name="Picture 72" descr="3139326610849488932.jpg"/>
+          <p:cNvPr id="73" name="Picture 72" descr="5248280226730105287.jpg"/>
           <p:cNvPicPr>
             <a:picLocks noChangeAspect="1"/>
           </p:cNvPicPr>
@@ -18725,6 +18725,447 @@
         <p:spPr>
           <a:xfrm>
             <a:off x="7458075" y="3962400"/>
+            <a:ext cx="2143125" cy="285750"/>
+          </a:xfrm>
+          <a:prstGeom prst="rect">
+            <a:avLst/>
+          </a:prstGeom>
+          <a:noFill/>
+        </p:spPr>
+        <p:txBody>
+          <a:bodyPr wrap="square" lIns="0" rIns="0" tIns="0" bIns="0" anchor="t">
+            <a:spAutoFit/>
+          </a:bodyPr>
+          <a:lstStyle/>
+          <a:p>
+            <a:pPr algn="l">
+              <a:lnSpc>
+                <a:spcPct val="120000"/>
+              </a:lnSpc>
+            </a:pPr>
+            <a:r>
+              <a:rPr sz="1800" b="0" i="0">
+                <a:solidFill>
+                  <a:srgbClr val="333130"/>
+                </a:solidFill>
+                <a:latin typeface="Source Sans 3"/>
+              </a:rPr>
+              <a:t>Dora Tkalec</a:t>
+            </a:r>
+          </a:p>
+        </p:txBody>
+      </p:sp>
+      <p:pic>
+        <p:nvPicPr>
+          <p:cNvPr id="75" name="Picture 74" descr="8537488814558054651.jpg"/>
+          <p:cNvPicPr>
+            <a:picLocks noChangeAspect="1"/>
+          </p:cNvPicPr>
+          <p:nvPr/>
+        </p:nvPicPr>
+        <p:blipFill>
+          <a:blip r:embed="rId6"/>
+          <a:stretch>
+            <a:fillRect/>
+          </a:stretch>
+        </p:blipFill>
+        <p:spPr>
+          <a:xfrm>
+            <a:off x="685800" y="4381500"/>
+            <a:ext cx="2143125" cy="2143125"/>
+          </a:xfrm>
+          <a:prstGeom prst="rect">
+            <a:avLst/>
+          </a:prstGeom>
+        </p:spPr>
+      </p:pic>
+      <p:sp>
+        <p:nvSpPr>
+          <p:cNvPr id="76" name="TextBox 75"/>
+          <p:cNvSpPr txBox="1"/>
+          <p:nvPr/>
+        </p:nvSpPr>
+        <p:spPr>
+          <a:xfrm>
+            <a:off x="685800" y="6581775"/>
+            <a:ext cx="2143125" cy="285750"/>
+          </a:xfrm>
+          <a:prstGeom prst="rect">
+            <a:avLst/>
+          </a:prstGeom>
+          <a:noFill/>
+        </p:spPr>
+        <p:txBody>
+          <a:bodyPr wrap="square" lIns="0" rIns="0" tIns="0" bIns="0" anchor="t">
+            <a:spAutoFit/>
+          </a:bodyPr>
+          <a:lstStyle/>
+          <a:p>
+            <a:pPr algn="l">
+              <a:lnSpc>
+                <a:spcPct val="120000"/>
+              </a:lnSpc>
+            </a:pPr>
+            <a:r>
+              <a:rPr sz="1800" b="0" i="0">
+                <a:solidFill>
+                  <a:srgbClr val="333130"/>
+                </a:solidFill>
+                <a:latin typeface="Source Sans 3"/>
+              </a:rPr>
+              <a:t>Elena Kalli</a:t>
+            </a:r>
+          </a:p>
+        </p:txBody>
+      </p:sp>
+      <p:pic>
+        <p:nvPicPr>
+          <p:cNvPr id="77" name="Picture 76" descr="5232482427252906244.jpg"/>
+          <p:cNvPicPr>
+            <a:picLocks noChangeAspect="1"/>
+          </p:cNvPicPr>
+          <p:nvPr/>
+        </p:nvPicPr>
+        <p:blipFill>
+          <a:blip r:embed="rId7"/>
+          <a:stretch>
+            <a:fillRect/>
+          </a:stretch>
+        </p:blipFill>
+        <p:spPr>
+          <a:xfrm>
+            <a:off x="2943225" y="4381500"/>
+            <a:ext cx="2143125" cy="2143125"/>
+          </a:xfrm>
+          <a:prstGeom prst="rect">
+            <a:avLst/>
+          </a:prstGeom>
+        </p:spPr>
+      </p:pic>
+      <p:sp>
+        <p:nvSpPr>
+          <p:cNvPr id="78" name="TextBox 77"/>
+          <p:cNvSpPr txBox="1"/>
+          <p:nvPr/>
+        </p:nvSpPr>
+        <p:spPr>
+          <a:xfrm>
+            <a:off x="2943225" y="6581775"/>
+            <a:ext cx="2143125" cy="285750"/>
+          </a:xfrm>
+          <a:prstGeom prst="rect">
+            <a:avLst/>
+          </a:prstGeom>
+          <a:noFill/>
+        </p:spPr>
+        <p:txBody>
+          <a:bodyPr wrap="square" lIns="0" rIns="0" tIns="0" bIns="0" anchor="t">
+            <a:spAutoFit/>
+          </a:bodyPr>
+          <a:lstStyle/>
+          <a:p>
+            <a:pPr algn="l">
+              <a:lnSpc>
+                <a:spcPct val="120000"/>
+              </a:lnSpc>
+            </a:pPr>
+            <a:r>
+              <a:rPr sz="1800" b="0" i="0">
+                <a:solidFill>
+                  <a:srgbClr val="333130"/>
+                </a:solidFill>
+                <a:latin typeface="Source Sans 3"/>
+              </a:rPr>
+              <a:t>Isadora Shmidt</a:t>
+            </a:r>
+          </a:p>
+        </p:txBody>
+      </p:sp>
+      <p:pic>
+        <p:nvPicPr>
+          <p:cNvPr id="79" name="Picture 78" descr="2935389191544078019.jpg"/>
+          <p:cNvPicPr>
+            <a:picLocks noChangeAspect="1"/>
+          </p:cNvPicPr>
+          <p:nvPr/>
+        </p:nvPicPr>
+        <p:blipFill>
+          <a:blip r:embed="rId8"/>
+          <a:stretch>
+            <a:fillRect/>
+          </a:stretch>
+        </p:blipFill>
+        <p:spPr>
+          <a:xfrm>
+            <a:off x="5200650" y="4381500"/>
+            <a:ext cx="2143125" cy="2143125"/>
+          </a:xfrm>
+          <a:prstGeom prst="rect">
+            <a:avLst/>
+          </a:prstGeom>
+        </p:spPr>
+      </p:pic>
+      <p:sp>
+        <p:nvSpPr>
+          <p:cNvPr id="80" name="TextBox 79"/>
+          <p:cNvSpPr txBox="1"/>
+          <p:nvPr/>
+        </p:nvSpPr>
+        <p:spPr>
+          <a:xfrm>
+            <a:off x="5200650" y="6581775"/>
+            <a:ext cx="2143125" cy="285750"/>
+          </a:xfrm>
+          <a:prstGeom prst="rect">
+            <a:avLst/>
+          </a:prstGeom>
+          <a:noFill/>
+        </p:spPr>
+        <p:txBody>
+          <a:bodyPr wrap="square" lIns="0" rIns="0" tIns="0" bIns="0" anchor="t">
+            <a:spAutoFit/>
+          </a:bodyPr>
+          <a:lstStyle/>
+          <a:p>
+            <a:pPr algn="l">
+              <a:lnSpc>
+                <a:spcPct val="120000"/>
+              </a:lnSpc>
+            </a:pPr>
+            <a:r>
+              <a:rPr sz="1800" b="0" i="0">
+                <a:solidFill>
+                  <a:srgbClr val="333130"/>
+                </a:solidFill>
+                <a:latin typeface="Source Sans 3"/>
+              </a:rPr>
+              <a:t>Gerald Ramírez</a:t>
+            </a:r>
+          </a:p>
+        </p:txBody>
+      </p:sp>
+      <p:pic>
+        <p:nvPicPr>
+          <p:cNvPr id="81" name="Picture 80" descr="931803531823155755.jpg"/>
+          <p:cNvPicPr>
+            <a:picLocks noChangeAspect="1"/>
+          </p:cNvPicPr>
+          <p:nvPr/>
+        </p:nvPicPr>
+        <p:blipFill>
+          <a:blip r:embed="rId9"/>
+          <a:stretch>
+            <a:fillRect/>
+          </a:stretch>
+        </p:blipFill>
+        <p:spPr>
+          <a:xfrm>
+            <a:off x="7458075" y="4381500"/>
+            <a:ext cx="2143125" cy="2143125"/>
+          </a:xfrm>
+          <a:prstGeom prst="rect">
+            <a:avLst/>
+          </a:prstGeom>
+        </p:spPr>
+      </p:pic>
+      <p:sp>
+        <p:nvSpPr>
+          <p:cNvPr id="82" name="TextBox 81"/>
+          <p:cNvSpPr txBox="1"/>
+          <p:nvPr/>
+        </p:nvSpPr>
+        <p:spPr>
+          <a:xfrm>
+            <a:off x="7458075" y="6581775"/>
+            <a:ext cx="2143125" cy="285750"/>
+          </a:xfrm>
+          <a:prstGeom prst="rect">
+            <a:avLst/>
+          </a:prstGeom>
+          <a:noFill/>
+        </p:spPr>
+        <p:txBody>
+          <a:bodyPr wrap="square" lIns="0" rIns="0" tIns="0" bIns="0" anchor="t">
+            <a:spAutoFit/>
+          </a:bodyPr>
+          <a:lstStyle/>
+          <a:p>
+            <a:pPr algn="l">
+              <a:lnSpc>
+                <a:spcPct val="120000"/>
+              </a:lnSpc>
+            </a:pPr>
+            <a:r>
+              <a:rPr sz="1800" b="0" i="0">
+                <a:solidFill>
+                  <a:srgbClr val="333130"/>
+                </a:solidFill>
+                <a:latin typeface="Source Sans 3"/>
+              </a:rPr>
+              <a:t>Tommy Tapper</a:t>
+            </a:r>
+          </a:p>
+        </p:txBody>
+      </p:sp>
+      <p:pic>
+        <p:nvPicPr>
+          <p:cNvPr id="83" name="Picture 82" descr="6898878685590571014.jpg"/>
+          <p:cNvPicPr>
+            <a:picLocks noChangeAspect="1"/>
+          </p:cNvPicPr>
+          <p:nvPr/>
+        </p:nvPicPr>
+        <p:blipFill>
+          <a:blip r:embed="rId10"/>
+          <a:stretch>
+            <a:fillRect/>
+          </a:stretch>
+        </p:blipFill>
+        <p:spPr>
+          <a:xfrm>
+            <a:off x="685800" y="7000875"/>
+            <a:ext cx="2143125" cy="2143125"/>
+          </a:xfrm>
+          <a:prstGeom prst="rect">
+            <a:avLst/>
+          </a:prstGeom>
+        </p:spPr>
+      </p:pic>
+      <p:sp>
+        <p:nvSpPr>
+          <p:cNvPr id="84" name="TextBox 83"/>
+          <p:cNvSpPr txBox="1"/>
+          <p:nvPr/>
+        </p:nvSpPr>
+        <p:spPr>
+          <a:xfrm>
+            <a:off x="685800" y="9201150"/>
+            <a:ext cx="2143125" cy="285750"/>
+          </a:xfrm>
+          <a:prstGeom prst="rect">
+            <a:avLst/>
+          </a:prstGeom>
+          <a:noFill/>
+        </p:spPr>
+        <p:txBody>
+          <a:bodyPr wrap="square" lIns="0" rIns="0" tIns="0" bIns="0" anchor="t">
+            <a:spAutoFit/>
+          </a:bodyPr>
+          <a:lstStyle/>
+          <a:p>
+            <a:pPr algn="l">
+              <a:lnSpc>
+                <a:spcPct val="120000"/>
+              </a:lnSpc>
+            </a:pPr>
+            <a:r>
+              <a:rPr sz="1800" b="0" i="0">
+                <a:solidFill>
+                  <a:srgbClr val="333130"/>
+                </a:solidFill>
+                <a:latin typeface="Source Sans 3"/>
+              </a:rPr>
+              <a:t>Loida Vasquez</a:t>
+            </a:r>
+          </a:p>
+        </p:txBody>
+      </p:sp>
+      <p:pic>
+        <p:nvPicPr>
+          <p:cNvPr id="85" name="Picture 84" descr="3121827617327194404.jpg"/>
+          <p:cNvPicPr>
+            <a:picLocks noChangeAspect="1"/>
+          </p:cNvPicPr>
+          <p:nvPr/>
+        </p:nvPicPr>
+        <p:blipFill>
+          <a:blip r:embed="rId11"/>
+          <a:stretch>
+            <a:fillRect/>
+          </a:stretch>
+        </p:blipFill>
+        <p:spPr>
+          <a:xfrm>
+            <a:off x="2943225" y="7000875"/>
+            <a:ext cx="2143125" cy="2143125"/>
+          </a:xfrm>
+          <a:prstGeom prst="rect">
+            <a:avLst/>
+          </a:prstGeom>
+        </p:spPr>
+      </p:pic>
+      <p:sp>
+        <p:nvSpPr>
+          <p:cNvPr id="86" name="TextBox 85"/>
+          <p:cNvSpPr txBox="1"/>
+          <p:nvPr/>
+        </p:nvSpPr>
+        <p:spPr>
+          <a:xfrm>
+            <a:off x="2943225" y="9201150"/>
+            <a:ext cx="2143125" cy="285750"/>
+          </a:xfrm>
+          <a:prstGeom prst="rect">
+            <a:avLst/>
+          </a:prstGeom>
+          <a:noFill/>
+        </p:spPr>
+        <p:txBody>
+          <a:bodyPr wrap="square" lIns="0" rIns="0" tIns="0" bIns="0" anchor="t">
+            <a:spAutoFit/>
+          </a:bodyPr>
+          <a:lstStyle/>
+          <a:p>
+            <a:pPr algn="l">
+              <a:lnSpc>
+                <a:spcPct val="120000"/>
+              </a:lnSpc>
+            </a:pPr>
+            <a:r>
+              <a:rPr sz="1800" b="0" i="0">
+                <a:solidFill>
+                  <a:srgbClr val="333130"/>
+                </a:solidFill>
+                <a:latin typeface="Source Sans 3"/>
+              </a:rPr>
+              <a:t>Carla Portugal</a:t>
+            </a:r>
+          </a:p>
+        </p:txBody>
+      </p:sp>
+      <p:pic>
+        <p:nvPicPr>
+          <p:cNvPr id="87" name="Picture 86" descr="6273480043131842505.jpg"/>
+          <p:cNvPicPr>
+            <a:picLocks noChangeAspect="1"/>
+          </p:cNvPicPr>
+          <p:nvPr/>
+        </p:nvPicPr>
+        <p:blipFill>
+          <a:blip r:embed="rId12"/>
+          <a:stretch>
+            <a:fillRect/>
+          </a:stretch>
+        </p:blipFill>
+        <p:spPr>
+          <a:xfrm>
+            <a:off x="5200650" y="7000875"/>
+            <a:ext cx="2143125" cy="2143125"/>
+          </a:xfrm>
+          <a:prstGeom prst="rect">
+            <a:avLst/>
+          </a:prstGeom>
+        </p:spPr>
+      </p:pic>
+      <p:sp>
+        <p:nvSpPr>
+          <p:cNvPr id="88" name="TextBox 87"/>
+          <p:cNvSpPr txBox="1"/>
+          <p:nvPr/>
+        </p:nvSpPr>
+        <p:spPr>
+          <a:xfrm>
+            <a:off x="5200650" y="9201150"/>
             <a:ext cx="2143125" cy="285750"/>
           </a:xfrm>
           <a:prstGeom prst="rect">
@@ -18757,448 +19198,7 @@
       </p:sp>
       <p:pic>
         <p:nvPicPr>
-          <p:cNvPr id="75" name="Picture 74" descr="2750903348445113879.jpg"/>
-          <p:cNvPicPr>
-            <a:picLocks noChangeAspect="1"/>
-          </p:cNvPicPr>
-          <p:nvPr/>
-        </p:nvPicPr>
-        <p:blipFill>
-          <a:blip r:embed="rId6"/>
-          <a:stretch>
-            <a:fillRect/>
-          </a:stretch>
-        </p:blipFill>
-        <p:spPr>
-          <a:xfrm>
-            <a:off x="685800" y="4381500"/>
-            <a:ext cx="2143125" cy="2143125"/>
-          </a:xfrm>
-          <a:prstGeom prst="rect">
-            <a:avLst/>
-          </a:prstGeom>
-        </p:spPr>
-      </p:pic>
-      <p:sp>
-        <p:nvSpPr>
-          <p:cNvPr id="76" name="TextBox 75"/>
-          <p:cNvSpPr txBox="1"/>
-          <p:nvPr/>
-        </p:nvSpPr>
-        <p:spPr>
-          <a:xfrm>
-            <a:off x="685800" y="6581775"/>
-            <a:ext cx="2143125" cy="285750"/>
-          </a:xfrm>
-          <a:prstGeom prst="rect">
-            <a:avLst/>
-          </a:prstGeom>
-          <a:noFill/>
-        </p:spPr>
-        <p:txBody>
-          <a:bodyPr wrap="square" lIns="0" rIns="0" tIns="0" bIns="0" anchor="t">
-            <a:spAutoFit/>
-          </a:bodyPr>
-          <a:lstStyle/>
-          <a:p>
-            <a:pPr algn="l">
-              <a:lnSpc>
-                <a:spcPct val="120000"/>
-              </a:lnSpc>
-            </a:pPr>
-            <a:r>
-              <a:rPr sz="1800" b="0" i="0">
-                <a:solidFill>
-                  <a:srgbClr val="333130"/>
-                </a:solidFill>
-                <a:latin typeface="Source Sans 3"/>
-              </a:rPr>
-              <a:t>Elena Kalli</a:t>
-            </a:r>
-          </a:p>
-        </p:txBody>
-      </p:sp>
-      <p:pic>
-        <p:nvPicPr>
-          <p:cNvPr id="77" name="Picture 76" descr="3794067675830285380.jpg"/>
-          <p:cNvPicPr>
-            <a:picLocks noChangeAspect="1"/>
-          </p:cNvPicPr>
-          <p:nvPr/>
-        </p:nvPicPr>
-        <p:blipFill>
-          <a:blip r:embed="rId7"/>
-          <a:stretch>
-            <a:fillRect/>
-          </a:stretch>
-        </p:blipFill>
-        <p:spPr>
-          <a:xfrm>
-            <a:off x="2943225" y="4381500"/>
-            <a:ext cx="2143125" cy="2143125"/>
-          </a:xfrm>
-          <a:prstGeom prst="rect">
-            <a:avLst/>
-          </a:prstGeom>
-        </p:spPr>
-      </p:pic>
-      <p:sp>
-        <p:nvSpPr>
-          <p:cNvPr id="78" name="TextBox 77"/>
-          <p:cNvSpPr txBox="1"/>
-          <p:nvPr/>
-        </p:nvSpPr>
-        <p:spPr>
-          <a:xfrm>
-            <a:off x="2943225" y="6581775"/>
-            <a:ext cx="2143125" cy="285750"/>
-          </a:xfrm>
-          <a:prstGeom prst="rect">
-            <a:avLst/>
-          </a:prstGeom>
-          <a:noFill/>
-        </p:spPr>
-        <p:txBody>
-          <a:bodyPr wrap="square" lIns="0" rIns="0" tIns="0" bIns="0" anchor="t">
-            <a:spAutoFit/>
-          </a:bodyPr>
-          <a:lstStyle/>
-          <a:p>
-            <a:pPr algn="l">
-              <a:lnSpc>
-                <a:spcPct val="120000"/>
-              </a:lnSpc>
-            </a:pPr>
-            <a:r>
-              <a:rPr sz="1800" b="0" i="0">
-                <a:solidFill>
-                  <a:srgbClr val="333130"/>
-                </a:solidFill>
-                <a:latin typeface="Source Sans 3"/>
-              </a:rPr>
-              <a:t>Isadora Shmidt</a:t>
-            </a:r>
-          </a:p>
-        </p:txBody>
-      </p:sp>
-      <p:pic>
-        <p:nvPicPr>
-          <p:cNvPr id="79" name="Picture 78" descr="3861038975520163185.jpg"/>
-          <p:cNvPicPr>
-            <a:picLocks noChangeAspect="1"/>
-          </p:cNvPicPr>
-          <p:nvPr/>
-        </p:nvPicPr>
-        <p:blipFill>
-          <a:blip r:embed="rId8"/>
-          <a:stretch>
-            <a:fillRect/>
-          </a:stretch>
-        </p:blipFill>
-        <p:spPr>
-          <a:xfrm>
-            <a:off x="5200650" y="4381500"/>
-            <a:ext cx="2143125" cy="2143125"/>
-          </a:xfrm>
-          <a:prstGeom prst="rect">
-            <a:avLst/>
-          </a:prstGeom>
-        </p:spPr>
-      </p:pic>
-      <p:sp>
-        <p:nvSpPr>
-          <p:cNvPr id="80" name="TextBox 79"/>
-          <p:cNvSpPr txBox="1"/>
-          <p:nvPr/>
-        </p:nvSpPr>
-        <p:spPr>
-          <a:xfrm>
-            <a:off x="5200650" y="6581775"/>
-            <a:ext cx="2143125" cy="285750"/>
-          </a:xfrm>
-          <a:prstGeom prst="rect">
-            <a:avLst/>
-          </a:prstGeom>
-          <a:noFill/>
-        </p:spPr>
-        <p:txBody>
-          <a:bodyPr wrap="square" lIns="0" rIns="0" tIns="0" bIns="0" anchor="t">
-            <a:spAutoFit/>
-          </a:bodyPr>
-          <a:lstStyle/>
-          <a:p>
-            <a:pPr algn="l">
-              <a:lnSpc>
-                <a:spcPct val="120000"/>
-              </a:lnSpc>
-            </a:pPr>
-            <a:r>
-              <a:rPr sz="1800" b="0" i="0">
-                <a:solidFill>
-                  <a:srgbClr val="333130"/>
-                </a:solidFill>
-                <a:latin typeface="Source Sans 3"/>
-              </a:rPr>
-              <a:t>Gerald Ramírez</a:t>
-            </a:r>
-          </a:p>
-        </p:txBody>
-      </p:sp>
-      <p:pic>
-        <p:nvPicPr>
-          <p:cNvPr id="81" name="Picture 80" descr="2935605721114179229.jpg"/>
-          <p:cNvPicPr>
-            <a:picLocks noChangeAspect="1"/>
-          </p:cNvPicPr>
-          <p:nvPr/>
-        </p:nvPicPr>
-        <p:blipFill>
-          <a:blip r:embed="rId9"/>
-          <a:stretch>
-            <a:fillRect/>
-          </a:stretch>
-        </p:blipFill>
-        <p:spPr>
-          <a:xfrm>
-            <a:off x="7458075" y="4381500"/>
-            <a:ext cx="2143125" cy="2143125"/>
-          </a:xfrm>
-          <a:prstGeom prst="rect">
-            <a:avLst/>
-          </a:prstGeom>
-        </p:spPr>
-      </p:pic>
-      <p:sp>
-        <p:nvSpPr>
-          <p:cNvPr id="82" name="TextBox 81"/>
-          <p:cNvSpPr txBox="1"/>
-          <p:nvPr/>
-        </p:nvSpPr>
-        <p:spPr>
-          <a:xfrm>
-            <a:off x="7458075" y="6581775"/>
-            <a:ext cx="2143125" cy="285750"/>
-          </a:xfrm>
-          <a:prstGeom prst="rect">
-            <a:avLst/>
-          </a:prstGeom>
-          <a:noFill/>
-        </p:spPr>
-        <p:txBody>
-          <a:bodyPr wrap="square" lIns="0" rIns="0" tIns="0" bIns="0" anchor="t">
-            <a:spAutoFit/>
-          </a:bodyPr>
-          <a:lstStyle/>
-          <a:p>
-            <a:pPr algn="l">
-              <a:lnSpc>
-                <a:spcPct val="120000"/>
-              </a:lnSpc>
-            </a:pPr>
-            <a:r>
-              <a:rPr sz="1800" b="0" i="0">
-                <a:solidFill>
-                  <a:srgbClr val="333130"/>
-                </a:solidFill>
-                <a:latin typeface="Source Sans 3"/>
-              </a:rPr>
-              <a:t>Tommy Tapper</a:t>
-            </a:r>
-          </a:p>
-        </p:txBody>
-      </p:sp>
-      <p:pic>
-        <p:nvPicPr>
-          <p:cNvPr id="83" name="Picture 82" descr="4642587556195066875.jpg"/>
-          <p:cNvPicPr>
-            <a:picLocks noChangeAspect="1"/>
-          </p:cNvPicPr>
-          <p:nvPr/>
-        </p:nvPicPr>
-        <p:blipFill>
-          <a:blip r:embed="rId10"/>
-          <a:stretch>
-            <a:fillRect/>
-          </a:stretch>
-        </p:blipFill>
-        <p:spPr>
-          <a:xfrm>
-            <a:off x="685800" y="7000875"/>
-            <a:ext cx="2143125" cy="2143125"/>
-          </a:xfrm>
-          <a:prstGeom prst="rect">
-            <a:avLst/>
-          </a:prstGeom>
-        </p:spPr>
-      </p:pic>
-      <p:sp>
-        <p:nvSpPr>
-          <p:cNvPr id="84" name="TextBox 83"/>
-          <p:cNvSpPr txBox="1"/>
-          <p:nvPr/>
-        </p:nvSpPr>
-        <p:spPr>
-          <a:xfrm>
-            <a:off x="685800" y="9201150"/>
-            <a:ext cx="2143125" cy="285750"/>
-          </a:xfrm>
-          <a:prstGeom prst="rect">
-            <a:avLst/>
-          </a:prstGeom>
-          <a:noFill/>
-        </p:spPr>
-        <p:txBody>
-          <a:bodyPr wrap="square" lIns="0" rIns="0" tIns="0" bIns="0" anchor="t">
-            <a:spAutoFit/>
-          </a:bodyPr>
-          <a:lstStyle/>
-          <a:p>
-            <a:pPr algn="l">
-              <a:lnSpc>
-                <a:spcPct val="120000"/>
-              </a:lnSpc>
-            </a:pPr>
-            <a:r>
-              <a:rPr sz="1800" b="0" i="0">
-                <a:solidFill>
-                  <a:srgbClr val="333130"/>
-                </a:solidFill>
-                <a:latin typeface="Source Sans 3"/>
-              </a:rPr>
-              <a:t>Loida Vasquez</a:t>
-            </a:r>
-          </a:p>
-        </p:txBody>
-      </p:sp>
-      <p:pic>
-        <p:nvPicPr>
-          <p:cNvPr id="85" name="Picture 84" descr="8694088384298960110.jpg"/>
-          <p:cNvPicPr>
-            <a:picLocks noChangeAspect="1"/>
-          </p:cNvPicPr>
-          <p:nvPr/>
-        </p:nvPicPr>
-        <p:blipFill>
-          <a:blip r:embed="rId11"/>
-          <a:stretch>
-            <a:fillRect/>
-          </a:stretch>
-        </p:blipFill>
-        <p:spPr>
-          <a:xfrm>
-            <a:off x="2943225" y="7000875"/>
-            <a:ext cx="2143125" cy="2143125"/>
-          </a:xfrm>
-          <a:prstGeom prst="rect">
-            <a:avLst/>
-          </a:prstGeom>
-        </p:spPr>
-      </p:pic>
-      <p:sp>
-        <p:nvSpPr>
-          <p:cNvPr id="86" name="TextBox 85"/>
-          <p:cNvSpPr txBox="1"/>
-          <p:nvPr/>
-        </p:nvSpPr>
-        <p:spPr>
-          <a:xfrm>
-            <a:off x="2943225" y="9201150"/>
-            <a:ext cx="2143125" cy="285750"/>
-          </a:xfrm>
-          <a:prstGeom prst="rect">
-            <a:avLst/>
-          </a:prstGeom>
-          <a:noFill/>
-        </p:spPr>
-        <p:txBody>
-          <a:bodyPr wrap="square" lIns="0" rIns="0" tIns="0" bIns="0" anchor="t">
-            <a:spAutoFit/>
-          </a:bodyPr>
-          <a:lstStyle/>
-          <a:p>
-            <a:pPr algn="l">
-              <a:lnSpc>
-                <a:spcPct val="120000"/>
-              </a:lnSpc>
-            </a:pPr>
-            <a:r>
-              <a:rPr sz="1800" b="0" i="0">
-                <a:solidFill>
-                  <a:srgbClr val="333130"/>
-                </a:solidFill>
-                <a:latin typeface="Source Sans 3"/>
-              </a:rPr>
-              <a:t>Carla Portugal</a:t>
-            </a:r>
-          </a:p>
-        </p:txBody>
-      </p:sp>
-      <p:pic>
-        <p:nvPicPr>
-          <p:cNvPr id="87" name="Picture 86" descr="8903105856644367317.jpg"/>
-          <p:cNvPicPr>
-            <a:picLocks noChangeAspect="1"/>
-          </p:cNvPicPr>
-          <p:nvPr/>
-        </p:nvPicPr>
-        <p:blipFill>
-          <a:blip r:embed="rId12"/>
-          <a:stretch>
-            <a:fillRect/>
-          </a:stretch>
-        </p:blipFill>
-        <p:spPr>
-          <a:xfrm>
-            <a:off x="5200650" y="7000875"/>
-            <a:ext cx="2143125" cy="2143125"/>
-          </a:xfrm>
-          <a:prstGeom prst="rect">
-            <a:avLst/>
-          </a:prstGeom>
-        </p:spPr>
-      </p:pic>
-      <p:sp>
-        <p:nvSpPr>
-          <p:cNvPr id="88" name="TextBox 87"/>
-          <p:cNvSpPr txBox="1"/>
-          <p:nvPr/>
-        </p:nvSpPr>
-        <p:spPr>
-          <a:xfrm>
-            <a:off x="5200650" y="9201150"/>
-            <a:ext cx="2143125" cy="285750"/>
-          </a:xfrm>
-          <a:prstGeom prst="rect">
-            <a:avLst/>
-          </a:prstGeom>
-          <a:noFill/>
-        </p:spPr>
-        <p:txBody>
-          <a:bodyPr wrap="square" lIns="0" rIns="0" tIns="0" bIns="0" anchor="t">
-            <a:spAutoFit/>
-          </a:bodyPr>
-          <a:lstStyle/>
-          <a:p>
-            <a:pPr algn="l">
-              <a:lnSpc>
-                <a:spcPct val="120000"/>
-              </a:lnSpc>
-            </a:pPr>
-            <a:r>
-              <a:rPr sz="1800" b="0" i="0">
-                <a:solidFill>
-                  <a:srgbClr val="333130"/>
-                </a:solidFill>
-                <a:latin typeface="Source Sans 3"/>
-              </a:rPr>
-              <a:t>Dora Tkalec</a:t>
-            </a:r>
-          </a:p>
-        </p:txBody>
-      </p:sp>
-      <p:pic>
-        <p:nvPicPr>
-          <p:cNvPr id="89" name="Picture 88" descr="118077776354024886.jpg"/>
+          <p:cNvPr id="89" name="Picture 88" descr="2459370116124079744.jpg"/>
           <p:cNvPicPr>
             <a:picLocks noChangeAspect="1"/>
           </p:cNvPicPr>
@@ -19261,7 +19261,7 @@
       </p:sp>
       <p:pic>
         <p:nvPicPr>
-          <p:cNvPr id="91" name="Picture 90" descr="6147693292793088277.jpg"/>
+          <p:cNvPr id="91" name="Picture 90" descr="5210732961209071061.jpg"/>
           <p:cNvPicPr>
             <a:picLocks noChangeAspect="1"/>
           </p:cNvPicPr>
@@ -19324,7 +19324,7 @@
       </p:sp>
       <p:pic>
         <p:nvPicPr>
-          <p:cNvPr id="93" name="Picture 92" descr="5986580262004156277.jpg"/>
+          <p:cNvPr id="93" name="Picture 92" descr="6818123601560314859.jpg"/>
           <p:cNvPicPr>
             <a:picLocks noChangeAspect="1"/>
           </p:cNvPicPr>
@@ -19387,7 +19387,7 @@
       </p:sp>
       <p:pic>
         <p:nvPicPr>
-          <p:cNvPr id="95" name="Picture 94" descr="5798608773535107475.jpg"/>
+          <p:cNvPr id="95" name="Picture 94" descr="2809537841490521723.jpg"/>
           <p:cNvPicPr>
             <a:picLocks noChangeAspect="1"/>
           </p:cNvPicPr>
@@ -19450,7 +19450,7 @@
       </p:sp>
       <p:pic>
         <p:nvPicPr>
-          <p:cNvPr id="97" name="Picture 96" descr="7250826599254344975.jpg"/>
+          <p:cNvPr id="97" name="Picture 96" descr="1871177202792540355.jpg"/>
           <p:cNvPicPr>
             <a:picLocks noChangeAspect="1"/>
           </p:cNvPicPr>

</xml_diff>